<commit_message>
Correccion presentación - Correccion en Readme
</commit_message>
<xml_diff>
--- a/Fase 1/Evidencias Grupales/Presentacion Proyecto.pptx
+++ b/Fase 1/Evidencias Grupales/Presentacion Proyecto.pptx
@@ -2046,7 +2046,7 @@
                 <a:ea typeface="Calibri" pitchFamily="34" charset="-122"/>
                 <a:cs typeface="Calibri" pitchFamily="34" charset="-120"/>
               </a:rPr>
-              <a:t>Framework de automatización de pruebas E2E para Front-End</a:t>
+              <a:t>Framework Plug &amp; Play de automatización de pruebas E2E para Front-End</a:t>
             </a:r>
             <a:endParaRPr lang="en-US" sz="1200" dirty="0"/>
           </a:p>
@@ -2235,7 +2235,7 @@
           <a:bodyPr/>
           <a:lstStyle/>
           <a:p>
-            <a:endParaRPr lang="es-CL"/>
+            <a:endParaRPr lang="es-CL" dirty="0"/>
           </a:p>
         </p:txBody>
       </p:sp>
@@ -2315,15 +2315,20 @@
               <a:buNone/>
             </a:pPr>
             <a:r>
-              <a:rPr lang="en-US" dirty="0">
-                <a:solidFill>
-                  <a:srgbClr val="5B6B79"/>
-                </a:solidFill>
+              <a:rPr lang="en-US" dirty="0" err="1">
                 <a:latin typeface="Calibri" pitchFamily="34" charset="0"/>
                 <a:ea typeface="Calibri" pitchFamily="34" charset="-122"/>
                 <a:cs typeface="Calibri" pitchFamily="34" charset="-120"/>
               </a:rPr>
-              <a:t>Automatización E2E con TypeScript/Python</a:t>
+              <a:t>Automatización</a:t>
+            </a:r>
+            <a:r>
+              <a:rPr lang="en-US" dirty="0">
+                <a:latin typeface="Calibri" pitchFamily="34" charset="0"/>
+                <a:ea typeface="Calibri" pitchFamily="34" charset="-122"/>
+                <a:cs typeface="Calibri" pitchFamily="34" charset="-120"/>
+              </a:rPr>
+              <a:t> E2E con TypeScript</a:t>
             </a:r>
             <a:endParaRPr lang="en-US" dirty="0"/>
           </a:p>
@@ -2440,9 +2445,6 @@
             </a:pPr>
             <a:r>
               <a:rPr lang="en-US" dirty="0">
-                <a:solidFill>
-                  <a:srgbClr val="5B6B79"/>
-                </a:solidFill>
                 <a:latin typeface="Calibri" pitchFamily="34" charset="0"/>
                 <a:ea typeface="Calibri" pitchFamily="34" charset="-122"/>
                 <a:cs typeface="Calibri" pitchFamily="34" charset="-120"/>
@@ -2564,9 +2566,6 @@
             </a:pPr>
             <a:r>
               <a:rPr lang="en-US" dirty="0">
-                <a:solidFill>
-                  <a:srgbClr val="5B6B79"/>
-                </a:solidFill>
                 <a:latin typeface="Calibri" pitchFamily="34" charset="0"/>
                 <a:ea typeface="Calibri" pitchFamily="34" charset="-122"/>
                 <a:cs typeface="Calibri" pitchFamily="34" charset="-120"/>
@@ -2585,7 +2584,7 @@
         </p:nvSpPr>
         <p:spPr>
           <a:xfrm>
-            <a:off x="457200" y="3749040"/>
+            <a:off x="441960" y="3749040"/>
             <a:ext cx="3611880" cy="1874520"/>
           </a:xfrm>
           <a:prstGeom prst="roundRect">
@@ -2687,15 +2686,8 @@
               <a:buNone/>
             </a:pPr>
             <a:r>
-              <a:rPr lang="en-US" dirty="0">
-                <a:solidFill>
-                  <a:srgbClr val="5B6B79"/>
-                </a:solidFill>
-                <a:latin typeface="Calibri" pitchFamily="34" charset="0"/>
-                <a:ea typeface="Calibri" pitchFamily="34" charset="-122"/>
-                <a:cs typeface="Calibri" pitchFamily="34" charset="-120"/>
-              </a:rPr>
-              <a:t>CI/CD para ejecuciones automatizadas</a:t>
+              <a:rPr lang="es-MX" dirty="0"/>
+              <a:t>Lenguaje principal estructurado y tipado</a:t>
             </a:r>
             <a:endParaRPr lang="en-US" dirty="0"/>
           </a:p>
@@ -2811,15 +2803,28 @@
               <a:buNone/>
             </a:pPr>
             <a:r>
-              <a:rPr lang="en-US" dirty="0">
-                <a:solidFill>
-                  <a:srgbClr val="5B6B79"/>
-                </a:solidFill>
+              <a:rPr lang="en-US" dirty="0" err="1">
                 <a:latin typeface="Calibri" pitchFamily="34" charset="0"/>
                 <a:ea typeface="Calibri" pitchFamily="34" charset="-122"/>
                 <a:cs typeface="Calibri" pitchFamily="34" charset="-120"/>
               </a:rPr>
-              <a:t>Reportes visuales de resultados de pruebas</a:t>
+              <a:t>Objetivos</a:t>
+            </a:r>
+            <a:r>
+              <a:rPr lang="en-US" dirty="0">
+                <a:latin typeface="Calibri" pitchFamily="34" charset="0"/>
+                <a:ea typeface="Calibri" pitchFamily="34" charset="-122"/>
+                <a:cs typeface="Calibri" pitchFamily="34" charset="-120"/>
+              </a:rPr>
+              <a:t> de </a:t>
+            </a:r>
+            <a:r>
+              <a:rPr lang="en-US" dirty="0" err="1">
+                <a:latin typeface="Calibri" pitchFamily="34" charset="0"/>
+                <a:ea typeface="Calibri" pitchFamily="34" charset="-122"/>
+                <a:cs typeface="Calibri" pitchFamily="34" charset="-120"/>
+              </a:rPr>
+              <a:t>pruebas</a:t>
             </a:r>
             <a:endParaRPr lang="en-US" dirty="0"/>
           </a:p>
@@ -2936,14 +2941,11 @@
             </a:pPr>
             <a:r>
               <a:rPr lang="en-US" dirty="0">
-                <a:solidFill>
-                  <a:srgbClr val="5B6B79"/>
-                </a:solidFill>
                 <a:latin typeface="Calibri" pitchFamily="34" charset="0"/>
                 <a:ea typeface="Calibri" pitchFamily="34" charset="-122"/>
                 <a:cs typeface="Calibri" pitchFamily="34" charset="-120"/>
               </a:rPr>
-              <a:t>Sistema Open Source usado como caso de aplicación</a:t>
+              <a:t>Validación aplicable a cualquier URL ingresada (Plug &amp; Play)</a:t>
             </a:r>
             <a:endParaRPr lang="en-US" dirty="0"/>
           </a:p>
@@ -3021,7 +3023,7 @@
                 <a:ea typeface="Calibri" pitchFamily="34" charset="-122"/>
                 <a:cs typeface="Calibri" pitchFamily="34" charset="-120"/>
               </a:rPr>
-              <a:t>8</a:t>
+              <a:t>10</a:t>
             </a:r>
             <a:endParaRPr lang="en-US" sz="900" dirty="0"/>
           </a:p>
@@ -3199,9 +3201,8 @@
                 </a:solidFill>
                 <a:latin typeface="Cambria" pitchFamily="34" charset="0"/>
                 <a:ea typeface="Cambria" pitchFamily="34" charset="-122"/>
-                <a:cs typeface="Cambria" pitchFamily="34" charset="-120"/>
-              </a:rPr>
-              <a:t>GitHub Actions</a:t>
+              </a:rPr>
+              <a:t>TypeScript</a:t>
             </a:r>
             <a:endParaRPr lang="en-US" sz="2000" dirty="0"/>
           </a:p>
@@ -3238,7 +3239,7 @@
               <a:buNone/>
             </a:pPr>
             <a:r>
-              <a:rPr lang="en-US" sz="2000" b="1" dirty="0">
+              <a:rPr lang="en-US" sz="2000" b="1" dirty="0" err="1">
                 <a:solidFill>
                   <a:srgbClr val="21295C"/>
                 </a:solidFill>
@@ -3246,7 +3247,7 @@
                 <a:ea typeface="Cambria" pitchFamily="34" charset="-122"/>
                 <a:cs typeface="Cambria" pitchFamily="34" charset="-120"/>
               </a:rPr>
-              <a:t>Allure Reports</a:t>
+              <a:t>Navegadores</a:t>
             </a:r>
             <a:endParaRPr lang="en-US" sz="2000" dirty="0"/>
           </a:p>
@@ -3291,7 +3292,7 @@
                 <a:ea typeface="Cambria" pitchFamily="34" charset="-122"/>
                 <a:cs typeface="Cambria" pitchFamily="34" charset="-120"/>
               </a:rPr>
-              <a:t>OrangeHRM</a:t>
+              <a:t>Escaneo Genérico</a:t>
             </a:r>
             <a:endParaRPr lang="en-US" sz="2000" dirty="0"/>
           </a:p>
@@ -3483,7 +3484,7 @@
                 <a:ea typeface="Calibri" pitchFamily="34" charset="-122"/>
                 <a:cs typeface="Calibri" pitchFamily="34" charset="-120"/>
               </a:rPr>
-              <a:t>Cronograma: 10 semanas operativas (semana 5 a semana 14) · 31 Puntos de Función</a:t>
+              <a:t>Cronograma: 10 semanas operativas (semana 5 a semana 14) · 35 Puntos de Función</a:t>
             </a:r>
             <a:endParaRPr lang="en-US" sz="2000" dirty="0"/>
           </a:p>
@@ -3491,7 +3492,7 @@
       </p:sp>
       <p:sp>
         <p:nvSpPr>
-          <p:cNvPr id="7" name="Text 4"/>
+          <p:cNvPr id="200" name="Label0"/>
           <p:cNvSpPr/>
           <p:nvPr/>
         </p:nvSpPr>
@@ -3522,7 +3523,7 @@
                 <a:ea typeface="Calibri" pitchFamily="34" charset="-122"/>
                 <a:cs typeface="Calibri" pitchFamily="34" charset="-120"/>
               </a:rPr>
-              <a:t>EP-001 Arquitectura Base (8 PF)</a:t>
+              <a:t>EP-001 Configuración Inicial (4 PF)</a:t>
             </a:r>
             <a:endParaRPr lang="en-US" dirty="0"/>
           </a:p>
@@ -3530,7 +3531,7 @@
       </p:sp>
       <p:sp>
         <p:nvSpPr>
-          <p:cNvPr id="8" name="Shape 5"/>
+          <p:cNvPr id="201" name="Lane0"/>
           <p:cNvSpPr/>
           <p:nvPr/>
         </p:nvSpPr>
@@ -3557,14 +3558,14 @@
       </p:sp>
       <p:sp>
         <p:nvSpPr>
-          <p:cNvPr id="9" name="Shape 6"/>
+          <p:cNvPr id="202" name="Bar0"/>
           <p:cNvSpPr/>
           <p:nvPr/>
         </p:nvSpPr>
         <p:spPr>
           <a:xfrm>
             <a:off x="4206240" y="2039112"/>
-            <a:ext cx="1505102" cy="310896"/>
+            <a:ext cx="752551" cy="310896"/>
           </a:xfrm>
           <a:prstGeom prst="roundRect">
             <a:avLst>
@@ -3586,7 +3587,7 @@
       </p:sp>
       <p:sp>
         <p:nvSpPr>
-          <p:cNvPr id="10" name="Text 7"/>
+          <p:cNvPr id="210" name="Label1"/>
           <p:cNvSpPr/>
           <p:nvPr/>
         </p:nvSpPr>
@@ -3617,7 +3618,7 @@
                 <a:ea typeface="Calibri" pitchFamily="34" charset="-122"/>
                 <a:cs typeface="Calibri" pitchFamily="34" charset="-120"/>
               </a:rPr>
-              <a:t>EP-002 Automatización UI (13 PF)</a:t>
+              <a:t>EP-002 Escaneo Automático (9 PF)</a:t>
             </a:r>
             <a:endParaRPr lang="en-US" dirty="0"/>
           </a:p>
@@ -3625,7 +3626,7 @@
       </p:sp>
       <p:sp>
         <p:nvSpPr>
-          <p:cNvPr id="11" name="Shape 8"/>
+          <p:cNvPr id="211" name="Lane1"/>
           <p:cNvSpPr/>
           <p:nvPr/>
         </p:nvSpPr>
@@ -3652,14 +3653,14 @@
       </p:sp>
       <p:sp>
         <p:nvSpPr>
-          <p:cNvPr id="12" name="Shape 9"/>
-          <p:cNvSpPr/>
-          <p:nvPr/>
-        </p:nvSpPr>
-        <p:spPr>
-          <a:xfrm>
-            <a:off x="5711342" y="2606040"/>
-            <a:ext cx="3010205" cy="310896"/>
+          <p:cNvPr id="212" name="Bar1"/>
+          <p:cNvSpPr/>
+          <p:nvPr/>
+        </p:nvSpPr>
+        <p:spPr>
+          <a:xfrm>
+            <a:off x="4958791" y="2606040"/>
+            <a:ext cx="2257654" cy="310896"/>
           </a:xfrm>
           <a:prstGeom prst="roundRect">
             <a:avLst>
@@ -3681,7 +3682,7 @@
       </p:sp>
       <p:sp>
         <p:nvSpPr>
-          <p:cNvPr id="13" name="Text 10"/>
+          <p:cNvPr id="220" name="Label2"/>
           <p:cNvSpPr/>
           <p:nvPr/>
         </p:nvSpPr>
@@ -3712,7 +3713,7 @@
                 <a:ea typeface="Calibri" pitchFamily="34" charset="-122"/>
                 <a:cs typeface="Calibri" pitchFamily="34" charset="-120"/>
               </a:rPr>
-              <a:t>EP-003 Integración Cloud (5 PF)</a:t>
+              <a:t>EP-003 Escenarios Genéricos (7 PF)</a:t>
             </a:r>
             <a:endParaRPr lang="en-US" dirty="0"/>
           </a:p>
@@ -3720,7 +3721,7 @@
       </p:sp>
       <p:sp>
         <p:nvSpPr>
-          <p:cNvPr id="14" name="Shape 11"/>
+          <p:cNvPr id="221" name="Lane2"/>
           <p:cNvSpPr/>
           <p:nvPr/>
         </p:nvSpPr>
@@ -3747,13 +3748,13 @@
       </p:sp>
       <p:sp>
         <p:nvSpPr>
-          <p:cNvPr id="15" name="Shape 12"/>
-          <p:cNvSpPr/>
-          <p:nvPr/>
-        </p:nvSpPr>
-        <p:spPr>
-          <a:xfrm>
-            <a:off x="8721547" y="3172968"/>
+          <p:cNvPr id="222" name="Bar2"/>
+          <p:cNvSpPr/>
+          <p:nvPr/>
+        </p:nvSpPr>
+        <p:spPr>
+          <a:xfrm>
+            <a:off x="6463894" y="3172968"/>
             <a:ext cx="1505102" cy="310896"/>
           </a:xfrm>
           <a:prstGeom prst="roundRect">
@@ -3776,7 +3777,7 @@
       </p:sp>
       <p:sp>
         <p:nvSpPr>
-          <p:cNvPr id="16" name="Text 13"/>
+          <p:cNvPr id="230" name="Label3"/>
           <p:cNvSpPr/>
           <p:nvPr/>
         </p:nvSpPr>
@@ -3807,7 +3808,7 @@
                 <a:ea typeface="Calibri" pitchFamily="34" charset="-122"/>
                 <a:cs typeface="Calibri" pitchFamily="34" charset="-120"/>
               </a:rPr>
-              <a:t>EP-004 Dashboard (5 PF)</a:t>
+              <a:t>EP-004 Adaptabilidad Dinámica (6 PF)</a:t>
             </a:r>
             <a:endParaRPr lang="en-US" dirty="0"/>
           </a:p>
@@ -3815,7 +3816,7 @@
       </p:sp>
       <p:sp>
         <p:nvSpPr>
-          <p:cNvPr id="17" name="Shape 14"/>
+          <p:cNvPr id="231" name="Lane3"/>
           <p:cNvSpPr/>
           <p:nvPr/>
         </p:nvSpPr>
@@ -3842,13 +3843,13 @@
       </p:sp>
       <p:sp>
         <p:nvSpPr>
-          <p:cNvPr id="18" name="Shape 15"/>
-          <p:cNvSpPr/>
-          <p:nvPr/>
-        </p:nvSpPr>
-        <p:spPr>
-          <a:xfrm>
-            <a:off x="9474098" y="3739896"/>
+          <p:cNvPr id="232" name="Bar3"/>
+          <p:cNvSpPr/>
+          <p:nvPr/>
+        </p:nvSpPr>
+        <p:spPr>
+          <a:xfrm>
+            <a:off x="7216445" y="3739896"/>
             <a:ext cx="1505102" cy="310896"/>
           </a:xfrm>
           <a:prstGeom prst="roundRect">
@@ -3871,7 +3872,7 @@
       </p:sp>
       <p:sp>
         <p:nvSpPr>
-          <p:cNvPr id="19" name="Text 16"/>
+          <p:cNvPr id="240" name="Label4"/>
           <p:cNvSpPr/>
           <p:nvPr/>
         </p:nvSpPr>
@@ -3902,7 +3903,7 @@
                 <a:ea typeface="Calibri" pitchFamily="34" charset="-122"/>
                 <a:cs typeface="Calibri" pitchFamily="34" charset="-120"/>
               </a:rPr>
-              <a:t>Estabilización, Informe y Defensa</a:t>
+              <a:t>EP-005 Ejecución en la Nube (5 PF)</a:t>
             </a:r>
             <a:endParaRPr lang="en-US" dirty="0"/>
           </a:p>
@@ -3910,7 +3911,7 @@
       </p:sp>
       <p:sp>
         <p:nvSpPr>
-          <p:cNvPr id="20" name="Shape 17"/>
+          <p:cNvPr id="241" name="Lane4"/>
           <p:cNvSpPr/>
           <p:nvPr/>
         </p:nvSpPr>
@@ -3937,13 +3938,13 @@
       </p:sp>
       <p:sp>
         <p:nvSpPr>
-          <p:cNvPr id="21" name="Shape 18"/>
-          <p:cNvSpPr/>
-          <p:nvPr/>
-        </p:nvSpPr>
-        <p:spPr>
-          <a:xfrm>
-            <a:off x="10226650" y="4306824"/>
+          <p:cNvPr id="242" name="Bar4"/>
+          <p:cNvSpPr/>
+          <p:nvPr/>
+        </p:nvSpPr>
+        <p:spPr>
+          <a:xfrm>
+            <a:off x="8721547" y="4306824"/>
             <a:ext cx="1505102" cy="310896"/>
           </a:xfrm>
           <a:prstGeom prst="roundRect">
@@ -3952,7 +3953,7 @@
             </a:avLst>
           </a:prstGeom>
           <a:solidFill>
-            <a:srgbClr val="21295C"/>
+            <a:srgbClr val="1C7293"/>
           </a:solidFill>
           <a:ln/>
         </p:spPr>
@@ -3966,14 +3967,14 @@
       </p:sp>
       <p:sp>
         <p:nvSpPr>
-          <p:cNvPr id="22" name="Text 19"/>
-          <p:cNvSpPr/>
-          <p:nvPr/>
-        </p:nvSpPr>
-        <p:spPr>
-          <a:xfrm>
-            <a:off x="4206240" y="4846320"/>
-            <a:ext cx="7525512" cy="274320"/>
+          <p:cNvPr id="250" name="Label5"/>
+          <p:cNvSpPr/>
+          <p:nvPr/>
+        </p:nvSpPr>
+        <p:spPr>
+          <a:xfrm>
+            <a:off x="457200" y="4800600"/>
+            <a:ext cx="3657600" cy="493776"/>
           </a:xfrm>
           <a:prstGeom prst="rect">
             <a:avLst/>
@@ -3991,13 +3992,13 @@
             <a:r>
               <a:rPr lang="en-US" dirty="0">
                 <a:solidFill>
-                  <a:srgbClr val="5B6B79"/>
+                  <a:srgbClr val="1B2733"/>
                 </a:solidFill>
                 <a:latin typeface="Calibri" pitchFamily="34" charset="0"/>
                 <a:ea typeface="Calibri" pitchFamily="34" charset="-122"/>
                 <a:cs typeface="Calibri" pitchFamily="34" charset="-120"/>
               </a:rPr>
-              <a:t>Semana 5                                                                                                  Semana 14</a:t>
+              <a:t>EP-006 Diagnóstico y Reportes (4 PF)</a:t>
             </a:r>
             <a:endParaRPr lang="en-US" dirty="0"/>
           </a:p>
@@ -4005,69 +4006,181 @@
       </p:sp>
       <p:sp>
         <p:nvSpPr>
-          <p:cNvPr id="23" name="Text 20"/>
-          <p:cNvSpPr/>
-          <p:nvPr/>
-        </p:nvSpPr>
-        <p:spPr>
-          <a:xfrm>
-            <a:off x="457200" y="6492240"/>
-            <a:ext cx="5486400" cy="274320"/>
-          </a:xfrm>
-          <a:prstGeom prst="rect">
-            <a:avLst/>
-          </a:prstGeom>
-          <a:noFill/>
-          <a:ln/>
-        </p:spPr>
-        <p:txBody>
-          <a:bodyPr wrap="square" rtlCol="0" anchor="ctr"/>
-          <a:lstStyle/>
-          <a:p>
-            <a:pPr marL="0" indent="0" algn="l">
-              <a:buNone/>
-            </a:pPr>
-            <a:r>
-              <a:rPr lang="en-US" sz="900" dirty="0">
-                <a:solidFill>
-                  <a:srgbClr val="5B6B79"/>
+          <p:cNvPr id="251" name="Lane5"/>
+          <p:cNvSpPr/>
+          <p:nvPr/>
+        </p:nvSpPr>
+        <p:spPr>
+          <a:xfrm>
+            <a:off x="4206240" y="4873752"/>
+            <a:ext cx="7525512" cy="310896"/>
+          </a:xfrm>
+          <a:prstGeom prst="rect">
+            <a:avLst/>
+          </a:prstGeom>
+          <a:solidFill>
+            <a:srgbClr val="E9EEF0"/>
+          </a:solidFill>
+          <a:ln/>
+        </p:spPr>
+        <p:txBody>
+          <a:bodyPr/>
+          <a:lstStyle/>
+          <a:p>
+            <a:endParaRPr lang="es-CL"/>
+          </a:p>
+        </p:txBody>
+      </p:sp>
+      <p:sp>
+        <p:nvSpPr>
+          <p:cNvPr id="252" name="Bar5"/>
+          <p:cNvSpPr/>
+          <p:nvPr/>
+        </p:nvSpPr>
+        <p:spPr>
+          <a:xfrm>
+            <a:off x="10226650" y="4873752"/>
+            <a:ext cx="1505102" cy="310896"/>
+          </a:xfrm>
+          <a:prstGeom prst="roundRect">
+            <a:avLst>
+              <a:gd name="adj" fmla="val 11765"/>
+            </a:avLst>
+          </a:prstGeom>
+          <a:solidFill>
+            <a:srgbClr val="1C7293"/>
+          </a:solidFill>
+          <a:ln/>
+        </p:spPr>
+        <p:txBody>
+          <a:bodyPr/>
+          <a:lstStyle/>
+          <a:p>
+            <a:endParaRPr lang="es-CL"/>
+          </a:p>
+        </p:txBody>
+      </p:sp>
+      <p:sp>
+        <p:nvSpPr>
+          <p:cNvPr id="260" name="Label6"/>
+          <p:cNvSpPr/>
+          <p:nvPr/>
+        </p:nvSpPr>
+        <p:spPr>
+          <a:xfrm>
+            <a:off x="457200" y="5367528"/>
+            <a:ext cx="3657600" cy="493776"/>
+          </a:xfrm>
+          <a:prstGeom prst="rect">
+            <a:avLst/>
+          </a:prstGeom>
+          <a:noFill/>
+          <a:ln/>
+        </p:spPr>
+        <p:txBody>
+          <a:bodyPr wrap="square" rtlCol="0" anchor="ctr"/>
+          <a:lstStyle/>
+          <a:p>
+            <a:pPr marL="0" indent="0">
+              <a:buNone/>
+            </a:pPr>
+            <a:r>
+              <a:rPr lang="en-US" dirty="0">
+                <a:solidFill>
+                  <a:srgbClr val="1B2733"/>
                 </a:solidFill>
                 <a:latin typeface="Calibri" pitchFamily="34" charset="0"/>
                 <a:ea typeface="Calibri" pitchFamily="34" charset="-122"/>
                 <a:cs typeface="Calibri" pitchFamily="34" charset="-120"/>
               </a:rPr>
-              <a:t>CACHAI-QA — Proyecto APT</a:t>
-            </a:r>
-            <a:endParaRPr lang="en-US" sz="900" dirty="0"/>
-          </a:p>
-        </p:txBody>
-      </p:sp>
-      <p:sp>
-        <p:nvSpPr>
-          <p:cNvPr id="24" name="Text 21"/>
-          <p:cNvSpPr/>
-          <p:nvPr/>
-        </p:nvSpPr>
-        <p:spPr>
-          <a:xfrm>
-            <a:off x="11274552" y="6492240"/>
-            <a:ext cx="457200" cy="274320"/>
-          </a:xfrm>
-          <a:prstGeom prst="rect">
-            <a:avLst/>
-          </a:prstGeom>
-          <a:noFill/>
-          <a:ln/>
-        </p:spPr>
-        <p:txBody>
-          <a:bodyPr wrap="square" rtlCol="0" anchor="ctr"/>
-          <a:lstStyle/>
-          <a:p>
-            <a:pPr marL="0" indent="0" algn="r">
-              <a:buNone/>
-            </a:pPr>
-            <a:r>
-              <a:rPr lang="en-US" sz="900" dirty="0">
+              <a:t>Estabilización, Informe y Defensa</a:t>
+            </a:r>
+            <a:endParaRPr lang="en-US" dirty="0"/>
+          </a:p>
+        </p:txBody>
+      </p:sp>
+      <p:sp>
+        <p:nvSpPr>
+          <p:cNvPr id="261" name="Lane6"/>
+          <p:cNvSpPr/>
+          <p:nvPr/>
+        </p:nvSpPr>
+        <p:spPr>
+          <a:xfrm>
+            <a:off x="4206240" y="5440680"/>
+            <a:ext cx="7525512" cy="310896"/>
+          </a:xfrm>
+          <a:prstGeom prst="rect">
+            <a:avLst/>
+          </a:prstGeom>
+          <a:solidFill>
+            <a:srgbClr val="E9EEF0"/>
+          </a:solidFill>
+          <a:ln/>
+        </p:spPr>
+        <p:txBody>
+          <a:bodyPr/>
+          <a:lstStyle/>
+          <a:p>
+            <a:endParaRPr lang="es-CL"/>
+          </a:p>
+        </p:txBody>
+      </p:sp>
+      <p:sp>
+        <p:nvSpPr>
+          <p:cNvPr id="262" name="Bar6"/>
+          <p:cNvSpPr/>
+          <p:nvPr/>
+        </p:nvSpPr>
+        <p:spPr>
+          <a:xfrm>
+            <a:off x="10979201" y="5440680"/>
+            <a:ext cx="752551" cy="310896"/>
+          </a:xfrm>
+          <a:prstGeom prst="roundRect">
+            <a:avLst>
+              <a:gd name="adj" fmla="val 11765"/>
+            </a:avLst>
+          </a:prstGeom>
+          <a:solidFill>
+            <a:srgbClr val="21295C"/>
+          </a:solidFill>
+          <a:ln/>
+        </p:spPr>
+        <p:txBody>
+          <a:bodyPr/>
+          <a:lstStyle/>
+          <a:p>
+            <a:endParaRPr lang="es-CL"/>
+          </a:p>
+        </p:txBody>
+      </p:sp>
+      <p:sp>
+        <p:nvSpPr>
+          <p:cNvPr id="22" name="Text 19"/>
+          <p:cNvSpPr/>
+          <p:nvPr/>
+        </p:nvSpPr>
+        <p:spPr>
+          <a:xfrm>
+            <a:off x="4206240" y="5934456"/>
+            <a:ext cx="7525512" cy="274320"/>
+          </a:xfrm>
+          <a:prstGeom prst="rect">
+            <a:avLst/>
+          </a:prstGeom>
+          <a:noFill/>
+          <a:ln/>
+        </p:spPr>
+        <p:txBody>
+          <a:bodyPr wrap="square" rtlCol="0" anchor="ctr"/>
+          <a:lstStyle/>
+          <a:p>
+            <a:pPr marL="0" indent="0">
+              <a:buNone/>
+            </a:pPr>
+            <a:r>
+              <a:rPr lang="en-US" dirty="0">
                 <a:solidFill>
                   <a:srgbClr val="5B6B79"/>
                 </a:solidFill>
@@ -4075,7 +4188,85 @@
                 <a:ea typeface="Calibri" pitchFamily="34" charset="-122"/>
                 <a:cs typeface="Calibri" pitchFamily="34" charset="-120"/>
               </a:rPr>
-              <a:t>9</a:t>
+              <a:t>Semana 5                                                                                                  Semana 14</a:t>
+            </a:r>
+            <a:endParaRPr lang="en-US" dirty="0"/>
+          </a:p>
+        </p:txBody>
+      </p:sp>
+      <p:sp>
+        <p:nvSpPr>
+          <p:cNvPr id="23" name="Text 20"/>
+          <p:cNvSpPr/>
+          <p:nvPr/>
+        </p:nvSpPr>
+        <p:spPr>
+          <a:xfrm>
+            <a:off x="457200" y="6492240"/>
+            <a:ext cx="5486400" cy="274320"/>
+          </a:xfrm>
+          <a:prstGeom prst="rect">
+            <a:avLst/>
+          </a:prstGeom>
+          <a:noFill/>
+          <a:ln/>
+        </p:spPr>
+        <p:txBody>
+          <a:bodyPr wrap="square" rtlCol="0" anchor="ctr"/>
+          <a:lstStyle/>
+          <a:p>
+            <a:pPr marL="0" indent="0" algn="l">
+              <a:buNone/>
+            </a:pPr>
+            <a:r>
+              <a:rPr lang="en-US" sz="900" dirty="0">
+                <a:solidFill>
+                  <a:srgbClr val="5B6B79"/>
+                </a:solidFill>
+                <a:latin typeface="Calibri" pitchFamily="34" charset="0"/>
+                <a:ea typeface="Calibri" pitchFamily="34" charset="-122"/>
+                <a:cs typeface="Calibri" pitchFamily="34" charset="-120"/>
+              </a:rPr>
+              <a:t>CACHAI-QA — Proyecto APT</a:t>
+            </a:r>
+            <a:endParaRPr lang="en-US" sz="900" dirty="0"/>
+          </a:p>
+        </p:txBody>
+      </p:sp>
+      <p:sp>
+        <p:nvSpPr>
+          <p:cNvPr id="24" name="Text 21"/>
+          <p:cNvSpPr/>
+          <p:nvPr/>
+        </p:nvSpPr>
+        <p:spPr>
+          <a:xfrm>
+            <a:off x="11274552" y="6492240"/>
+            <a:ext cx="457200" cy="274320"/>
+          </a:xfrm>
+          <a:prstGeom prst="rect">
+            <a:avLst/>
+          </a:prstGeom>
+          <a:noFill/>
+          <a:ln/>
+        </p:spPr>
+        <p:txBody>
+          <a:bodyPr wrap="square" rtlCol="0" anchor="ctr"/>
+          <a:lstStyle/>
+          <a:p>
+            <a:pPr marL="0" indent="0" algn="r">
+              <a:buNone/>
+            </a:pPr>
+            <a:r>
+              <a:rPr lang="en-US" sz="900" dirty="0">
+                <a:solidFill>
+                  <a:srgbClr val="5B6B79"/>
+                </a:solidFill>
+                <a:latin typeface="Calibri" pitchFamily="34" charset="0"/>
+                <a:ea typeface="Calibri" pitchFamily="34" charset="-122"/>
+                <a:cs typeface="Calibri" pitchFamily="34" charset="-120"/>
+              </a:rPr>
+              <a:t>11</a:t>
             </a:r>
             <a:endParaRPr lang="en-US" sz="900" dirty="0"/>
           </a:p>
@@ -4335,7 +4526,7 @@
                 <a:ea typeface="Calibri" pitchFamily="34" charset="-122"/>
                 <a:cs typeface="Calibri" pitchFamily="34" charset="-120"/>
               </a:rPr>
-              <a:t>Cobertura de flujos críticos: Login, Búsqueda/Filtro y Checkout</a:t>
+              <a:t>Cobertura de las reglas de calidad genéricas en cualquier página evaluada</a:t>
             </a:r>
             <a:endParaRPr lang="en-US" dirty="0"/>
           </a:p>
@@ -4588,7 +4779,7 @@
                 <a:ea typeface="Calibri" pitchFamily="34" charset="-122"/>
                 <a:cs typeface="Calibri" pitchFamily="34" charset="-120"/>
               </a:rPr>
-              <a:t>Reportes automatizados con métricas claras de calidad del software (Allure Reports + GitHub Actions).</a:t>
+              <a:t>Reportes automatizados con métricas claras de calidad del software.</a:t>
             </a:r>
             <a:endParaRPr lang="en-US" sz="1300" dirty="0"/>
           </a:p>
@@ -4751,7 +4942,7 @@
                 <a:ea typeface="Calibri" pitchFamily="34" charset="-122"/>
                 <a:cs typeface="Calibri" pitchFamily="34" charset="-120"/>
               </a:rPr>
-              <a:t>10</a:t>
+              <a:t>12</a:t>
             </a:r>
             <a:endParaRPr lang="en-US" sz="900" dirty="0"/>
           </a:p>
@@ -4992,7 +5183,7 @@
                 <a:ea typeface="Calibri" pitchFamily="34" charset="-122"/>
                 <a:cs typeface="Calibri" pitchFamily="34" charset="-120"/>
               </a:rPr>
-              <a:t>Se vincula al perfil de egreso en Diseño de Software y Resolución de Problemas</a:t>
+              <a:t>Se vincula al perfil de egreso en aseguramiento de calidad e ingeniería de software</a:t>
             </a:r>
             <a:endParaRPr lang="en-US" dirty="0"/>
           </a:p>
@@ -5112,7 +5303,7 @@
                 <a:ea typeface="Calibri" pitchFamily="34" charset="-122"/>
                 <a:cs typeface="Calibri" pitchFamily="34" charset="-120"/>
               </a:rPr>
-              <a:t>11</a:t>
+              <a:t>13</a:t>
             </a:r>
             <a:endParaRPr lang="en-US" sz="900" dirty="0"/>
           </a:p>
@@ -5428,9 +5619,6 @@
             </a:pPr>
             <a:r>
               <a:rPr lang="en-US" sz="1600" dirty="0">
-                <a:solidFill>
-                  <a:srgbClr val="5B6B79"/>
-                </a:solidFill>
                 <a:latin typeface="Calibri" pitchFamily="34" charset="0"/>
                 <a:ea typeface="Calibri" pitchFamily="34" charset="-122"/>
                 <a:cs typeface="Calibri" pitchFamily="34" charset="-120"/>
@@ -5598,9 +5786,6 @@
             </a:pPr>
             <a:r>
               <a:rPr lang="en-US" sz="1600" dirty="0">
-                <a:solidFill>
-                  <a:srgbClr val="5B6B79"/>
-                </a:solidFill>
                 <a:latin typeface="Calibri" pitchFamily="34" charset="0"/>
                 <a:ea typeface="Calibri" pitchFamily="34" charset="-122"/>
                 <a:cs typeface="Calibri" pitchFamily="34" charset="-120"/>
@@ -5768,9 +5953,6 @@
             </a:pPr>
             <a:r>
               <a:rPr lang="en-US" sz="1600" dirty="0">
-                <a:solidFill>
-                  <a:srgbClr val="5B6B79"/>
-                </a:solidFill>
                 <a:latin typeface="Calibri" pitchFamily="34" charset="0"/>
                 <a:ea typeface="Calibri" pitchFamily="34" charset="-122"/>
                 <a:cs typeface="Calibri" pitchFamily="34" charset="-120"/>
@@ -6213,7 +6395,7 @@
                 <a:ea typeface="Calibri" pitchFamily="34" charset="-122"/>
                 <a:cs typeface="Calibri" pitchFamily="34" charset="-120"/>
               </a:rPr>
-              <a:t>Diseñar e implementar la arquitectura base del framework (Playwright + POM)</a:t>
+              <a:t>Configurar el framework Plug &amp; Play ingresando únicamente la URL a evaluar</a:t>
             </a:r>
             <a:endParaRPr lang="en-US" dirty="0"/>
           </a:p>
@@ -6352,7 +6534,7 @@
                 <a:ea typeface="Calibri" pitchFamily="34" charset="-122"/>
                 <a:cs typeface="Calibri" pitchFamily="34" charset="-120"/>
               </a:rPr>
-              <a:t>Automatizar los flujos transaccionales críticos: Login, Búsqueda/Filtro y Checkout</a:t>
+              <a:t>Escanear automáticamente la página y detectar enlaces, imágenes y formularios</a:t>
             </a:r>
             <a:endParaRPr lang="en-US" dirty="0"/>
           </a:p>
@@ -6491,7 +6673,7 @@
                 <a:ea typeface="Calibri" pitchFamily="34" charset="-122"/>
                 <a:cs typeface="Calibri" pitchFamily="34" charset="-120"/>
               </a:rPr>
-              <a:t>Integrar ejecución remota y paralela en la nube con BrowserStack</a:t>
+              <a:t>Generar escenarios de prueba genéricos en lenguaje natural, adaptables a cada página</a:t>
             </a:r>
             <a:endParaRPr lang="en-US" dirty="0"/>
           </a:p>
@@ -6630,7 +6812,7 @@
                 <a:ea typeface="Calibri" pitchFamily="34" charset="-122"/>
                 <a:cs typeface="Calibri" pitchFamily="34" charset="-120"/>
               </a:rPr>
-              <a:t>Implementar telemetría y un dashboard de reportabilidad</a:t>
+              <a:t>Ejecutar las pruebas en la nube con BrowserStack y generar un reporte visual de diagnóstico</a:t>
             </a:r>
             <a:endParaRPr lang="en-US" dirty="0"/>
           </a:p>
@@ -7177,7 +7359,7 @@
         </p:nvSpPr>
         <p:spPr>
           <a:xfrm>
-            <a:off x="6126480" y="1828800"/>
+            <a:off x="6111850" y="1828800"/>
             <a:ext cx="2606040" cy="3677712"/>
           </a:xfrm>
           <a:prstGeom prst="roundRect">
@@ -7279,15 +7461,14 @@
               <a:buNone/>
             </a:pPr>
             <a:r>
-              <a:rPr lang="en-US" sz="2000" b="1" dirty="0">
+              <a:rPr lang="en-US" sz="2000" b="1" dirty="0" err="1">
                 <a:solidFill>
                   <a:srgbClr val="21295C"/>
                 </a:solidFill>
                 <a:latin typeface="Cambria" pitchFamily="34" charset="0"/>
                 <a:ea typeface="Cambria" pitchFamily="34" charset="-122"/>
-                <a:cs typeface="Cambria" pitchFamily="34" charset="-120"/>
-              </a:rPr>
-              <a:t>GitHub Actions</a:t>
+              </a:rPr>
+              <a:t>BrowserStack</a:t>
             </a:r>
             <a:endParaRPr lang="en-US" sz="2000" dirty="0"/>
           </a:p>
@@ -7328,7 +7509,7 @@
         </p:nvSpPr>
         <p:spPr>
           <a:xfrm>
-            <a:off x="8961120" y="1828799"/>
+            <a:off x="8967978" y="1828799"/>
             <a:ext cx="2606040" cy="3677707"/>
           </a:xfrm>
           <a:prstGeom prst="roundRect">
@@ -7470,14 +7651,11 @@
             </a:pPr>
             <a:r>
               <a:rPr lang="en-US" sz="1300" i="1" dirty="0">
-                <a:solidFill>
-                  <a:srgbClr val="5B6B79"/>
-                </a:solidFill>
                 <a:latin typeface="Calibri" pitchFamily="34" charset="0"/>
                 <a:ea typeface="Calibri" pitchFamily="34" charset="-122"/>
                 <a:cs typeface="Calibri" pitchFamily="34" charset="-120"/>
               </a:rPr>
-              <a:t>El framework se aplica sobre el sistema Open Source OrangeHRM para demostrar su viabilidad técnica.</a:t>
+              <a:t>El usuario solo ingresa la URL; el framework escanea la página y genera las pruebas automáticamente.</a:t>
             </a:r>
             <a:endParaRPr lang="en-US" sz="1300" dirty="0"/>
           </a:p>
@@ -7593,14 +7771,11 @@
             </a:pPr>
             <a:r>
               <a:rPr lang="en-US" dirty="0">
-                <a:solidFill>
-                  <a:srgbClr val="5B6B79"/>
-                </a:solidFill>
                 <a:latin typeface="Calibri" pitchFamily="34" charset="0"/>
                 <a:ea typeface="Calibri" pitchFamily="34" charset="-122"/>
                 <a:cs typeface="Calibri" pitchFamily="34" charset="-120"/>
               </a:rPr>
-              <a:t>Automatización sobre OrangeHRM (RRHH, Open Source)</a:t>
+              <a:t>Escaneo automático de cualquier página web (Plug &amp; Play)</a:t>
             </a:r>
             <a:endParaRPr lang="en-US" dirty="0"/>
           </a:p>
@@ -7638,9 +7813,6 @@
             </a:pPr>
             <a:r>
               <a:rPr lang="en-US" dirty="0">
-                <a:solidFill>
-                  <a:srgbClr val="5B6B79"/>
-                </a:solidFill>
                 <a:latin typeface="Calibri" pitchFamily="34" charset="0"/>
                 <a:ea typeface="Calibri" pitchFamily="34" charset="-122"/>
                 <a:cs typeface="Calibri" pitchFamily="34" charset="-120"/>
@@ -7682,15 +7854,8 @@
               <a:buNone/>
             </a:pPr>
             <a:r>
-              <a:rPr lang="en-US" dirty="0">
-                <a:solidFill>
-                  <a:srgbClr val="5B6B79"/>
-                </a:solidFill>
-                <a:latin typeface="Calibri" pitchFamily="34" charset="0"/>
-                <a:ea typeface="Calibri" pitchFamily="34" charset="-122"/>
-                <a:cs typeface="Calibri" pitchFamily="34" charset="-120"/>
-              </a:rPr>
-              <a:t>Reportes visuales automatizados en cada ejecución</a:t>
+              <a:rPr lang="es-MX" dirty="0"/>
+              <a:t>Ejecutar las pruebas de forma remota en distintos</a:t>
             </a:r>
             <a:endParaRPr lang="en-US" dirty="0"/>
           </a:p>
@@ -7728,9 +7893,6 @@
             </a:pPr>
             <a:r>
               <a:rPr lang="en-US" dirty="0">
-                <a:solidFill>
-                  <a:srgbClr val="5B6B79"/>
-                </a:solidFill>
                 <a:latin typeface="Calibri" pitchFamily="34" charset="0"/>
                 <a:ea typeface="Calibri" pitchFamily="34" charset="-122"/>
                 <a:cs typeface="Calibri" pitchFamily="34" charset="-120"/>
@@ -8027,7 +8189,7 @@
                 <a:ea typeface="Calibri" pitchFamily="34" charset="-122"/>
                 <a:cs typeface="Calibri" pitchFamily="34" charset="-120"/>
               </a:rPr>
-              <a:t>GitHub Actions inicia la suite de pruebas en modo headless</a:t>
+              <a:t>El usuario instala el sistema e ingresa la URL en la configuración inicial</a:t>
             </a:r>
             <a:endParaRPr lang="en-US" dirty="0"/>
           </a:p>
@@ -8166,7 +8328,7 @@
                 <a:ea typeface="Calibri" pitchFamily="34" charset="-122"/>
                 <a:cs typeface="Calibri" pitchFamily="34" charset="-120"/>
               </a:rPr>
-              <a:t>Playwright abre el navegador y accede a OrangeHRM</a:t>
+              <a:t>El framework abre la URL y escanea sus elementos principales</a:t>
             </a:r>
             <a:endParaRPr lang="en-US" dirty="0"/>
           </a:p>
@@ -8305,7 +8467,7 @@
                 <a:ea typeface="Calibri" pitchFamily="34" charset="-122"/>
                 <a:cs typeface="Calibri" pitchFamily="34" charset="-120"/>
               </a:rPr>
-              <a:t>Ingreso seguro de credenciales y acceso al panel principal</a:t>
+              <a:t>Se ejecutan escenarios de prueba genéricos (carga, enlaces rotos, errores)</a:t>
             </a:r>
             <a:endParaRPr lang="en-US" dirty="0"/>
           </a:p>
@@ -8444,7 +8606,7 @@
                 <a:ea typeface="Calibri" pitchFamily="34" charset="-122"/>
                 <a:cs typeface="Calibri" pitchFamily="34" charset="-120"/>
               </a:rPr>
-              <a:t>Navegación al módulo PIM y creación de un nuevo empleado</a:t>
+              <a:t>Las pruebas corren de forma remota e invisible en la nube con BrowserStack</a:t>
             </a:r>
             <a:endParaRPr lang="en-US" dirty="0"/>
           </a:p>
@@ -8583,7 +8745,7 @@
                 <a:ea typeface="Calibri" pitchFamily="34" charset="-122"/>
                 <a:cs typeface="Calibri" pitchFamily="34" charset="-120"/>
               </a:rPr>
-              <a:t>Validación del mensaje de éxito en el Front-End</a:t>
+              <a:t>Se genera un panel visual con los resultados de cada prueba</a:t>
             </a:r>
             <a:endParaRPr lang="en-US" dirty="0"/>
           </a:p>
@@ -8722,7 +8884,7 @@
                 <a:ea typeface="Calibri" pitchFamily="34" charset="-122"/>
                 <a:cs typeface="Calibri" pitchFamily="34" charset="-120"/>
               </a:rPr>
-              <a:t>Allure Reports publica el reporte visual de resultados</a:t>
+              <a:t>El usuario recibe el enlace con el diagnóstico de la URL evaluada</a:t>
             </a:r>
             <a:endParaRPr lang="en-US" dirty="0"/>
           </a:p>
@@ -8790,7 +8952,7 @@
                 <a:ea typeface="Calibri" pitchFamily="34" charset="-122"/>
                 <a:cs typeface="Calibri" pitchFamily="34" charset="-120"/>
               </a:rPr>
-              <a:t>Secuencia end-to-end desatendida: desde el disparo del pipeline hasta el reporte final de resultados.</a:t>
+              <a:t>Secuencia end-to-end desatendida: desde el ingreso de la URL hasta el reporte final de resultados.</a:t>
             </a:r>
             <a:endParaRPr lang="en-US" sz="1300" dirty="0"/>
           </a:p>
@@ -9775,7 +9937,7 @@
                 <a:latin typeface="Cambria" pitchFamily="34" charset="0"/>
                 <a:ea typeface="Cambria" pitchFamily="34" charset="-122"/>
               </a:rPr>
-              <a:t>3</a:t>
+              <a:t>6</a:t>
             </a:r>
             <a:endParaRPr lang="en-US" sz="1800" dirty="0"/>
           </a:p>
@@ -9992,63 +10154,8 @@
                 <a:ea typeface="Calibri" panose="020F0502020204030204" pitchFamily="34" charset="0"/>
                 <a:cs typeface="Times New Roman" panose="02020603050405020304" pitchFamily="18" charset="0"/>
               </a:rPr>
-              <a:t>El pipeline de </a:t>
-            </a:r>
-            <a:r>
-              <a:rPr lang="es-AR" sz="1600" dirty="0" err="1">
-                <a:effectLst/>
-                <a:latin typeface="Calibri" panose="020F0502020204030204" pitchFamily="34" charset="0"/>
-                <a:ea typeface="Calibri" panose="020F0502020204030204" pitchFamily="34" charset="0"/>
-                <a:cs typeface="Times New Roman" panose="02020603050405020304" pitchFamily="18" charset="0"/>
-              </a:rPr>
-              <a:t>Github</a:t>
-            </a:r>
-            <a:r>
-              <a:rPr lang="es-AR" sz="1600" dirty="0">
-                <a:effectLst/>
-                <a:latin typeface="Calibri" panose="020F0502020204030204" pitchFamily="34" charset="0"/>
-                <a:ea typeface="Calibri" panose="020F0502020204030204" pitchFamily="34" charset="0"/>
-                <a:cs typeface="Times New Roman" panose="02020603050405020304" pitchFamily="18" charset="0"/>
-              </a:rPr>
-              <a:t> </a:t>
-            </a:r>
-            <a:r>
-              <a:rPr lang="es-AR" sz="1600" dirty="0" err="1">
-                <a:effectLst/>
-                <a:latin typeface="Calibri" panose="020F0502020204030204" pitchFamily="34" charset="0"/>
-                <a:ea typeface="Calibri" panose="020F0502020204030204" pitchFamily="34" charset="0"/>
-                <a:cs typeface="Times New Roman" panose="02020603050405020304" pitchFamily="18" charset="0"/>
-              </a:rPr>
-              <a:t>Actions</a:t>
-            </a:r>
-            <a:r>
-              <a:rPr lang="es-AR" sz="1600" dirty="0">
-                <a:effectLst/>
-                <a:latin typeface="Calibri" panose="020F0502020204030204" pitchFamily="34" charset="0"/>
-                <a:ea typeface="Calibri" panose="020F0502020204030204" pitchFamily="34" charset="0"/>
-                <a:cs typeface="Times New Roman" panose="02020603050405020304" pitchFamily="18" charset="0"/>
-              </a:rPr>
-              <a:t> inicia la ejecución de la suite de pruebas en modo </a:t>
-            </a:r>
-            <a:r>
-              <a:rPr lang="es-AR" sz="1600" dirty="0" err="1">
-                <a:effectLst/>
-                <a:latin typeface="Calibri" panose="020F0502020204030204" pitchFamily="34" charset="0"/>
-                <a:ea typeface="Calibri" panose="020F0502020204030204" pitchFamily="34" charset="0"/>
-                <a:cs typeface="Times New Roman" panose="02020603050405020304" pitchFamily="18" charset="0"/>
-              </a:rPr>
-              <a:t>headless</a:t>
-            </a:r>
-            <a:r>
-              <a:rPr lang="es-AR" sz="1600" dirty="0">
-                <a:effectLst/>
-                <a:latin typeface="Calibri" panose="020F0502020204030204" pitchFamily="34" charset="0"/>
-                <a:ea typeface="Calibri" panose="020F0502020204030204" pitchFamily="34" charset="0"/>
-                <a:cs typeface="Times New Roman" panose="02020603050405020304" pitchFamily="18" charset="0"/>
-              </a:rPr>
-              <a:t> (es decir sin interfaz grafica).</a:t>
-            </a:r>
-            <a:endParaRPr lang="es-CL" sz="1600" dirty="0"/>
+              <a:t>El usuario instala el sistema y, en el archivo de configuración inicial, ingresa únicamente la URL a revisar.</a:t>
+            </a:r>
           </a:p>
         </p:txBody>
       </p:sp>
@@ -10087,45 +10194,8 @@
                 <a:ea typeface="Calibri" panose="020F0502020204030204" pitchFamily="34" charset="0"/>
                 <a:cs typeface="Times New Roman" panose="02020603050405020304" pitchFamily="18" charset="0"/>
               </a:rPr>
-              <a:t>El </a:t>
-            </a:r>
-            <a:r>
-              <a:rPr lang="es-AR" sz="1600" dirty="0" err="1">
-                <a:effectLst/>
-                <a:latin typeface="Calibri" panose="020F0502020204030204" pitchFamily="34" charset="0"/>
-                <a:ea typeface="Calibri" panose="020F0502020204030204" pitchFamily="34" charset="0"/>
-                <a:cs typeface="Times New Roman" panose="02020603050405020304" pitchFamily="18" charset="0"/>
-              </a:rPr>
-              <a:t>framework</a:t>
-            </a:r>
-            <a:r>
-              <a:rPr lang="es-AR" sz="1600" dirty="0">
-                <a:effectLst/>
-                <a:latin typeface="Calibri" panose="020F0502020204030204" pitchFamily="34" charset="0"/>
-                <a:ea typeface="Calibri" panose="020F0502020204030204" pitchFamily="34" charset="0"/>
-                <a:cs typeface="Times New Roman" panose="02020603050405020304" pitchFamily="18" charset="0"/>
-              </a:rPr>
-              <a:t> (Playwright) abre el navegador y navega hacia la pagina de inicio de sesión de </a:t>
-            </a:r>
-            <a:r>
-              <a:rPr lang="es-AR" sz="1600" dirty="0" err="1">
-                <a:effectLst/>
-                <a:latin typeface="Calibri" panose="020F0502020204030204" pitchFamily="34" charset="0"/>
-                <a:ea typeface="Calibri" panose="020F0502020204030204" pitchFamily="34" charset="0"/>
-                <a:cs typeface="Times New Roman" panose="02020603050405020304" pitchFamily="18" charset="0"/>
-              </a:rPr>
-              <a:t>OrangeHRM</a:t>
-            </a:r>
-            <a:r>
-              <a:rPr lang="es-AR" sz="1600" dirty="0">
-                <a:effectLst/>
-                <a:latin typeface="Calibri" panose="020F0502020204030204" pitchFamily="34" charset="0"/>
-                <a:ea typeface="Calibri" panose="020F0502020204030204" pitchFamily="34" charset="0"/>
-                <a:cs typeface="Times New Roman" panose="02020603050405020304" pitchFamily="18" charset="0"/>
-              </a:rPr>
-              <a:t>.</a:t>
-            </a:r>
-            <a:endParaRPr lang="es-CL" sz="1600" dirty="0"/>
+              <a:t>Al iniciar, el framework abre la URL y escanea automáticamente sus elementos principales (enlaces, imágenes, formularios).</a:t>
+            </a:r>
           </a:p>
         </p:txBody>
       </p:sp>
@@ -10164,9 +10234,8 @@
                 <a:ea typeface="Calibri" panose="020F0502020204030204" pitchFamily="34" charset="0"/>
                 <a:cs typeface="Times New Roman" panose="02020603050405020304" pitchFamily="18" charset="0"/>
               </a:rPr>
-              <a:t>El sistema ingresa las credenciales de administrador de forma segura y accede al panel principal.</a:t>
-            </a:r>
-            <a:endParaRPr lang="es-CL" sz="1600" dirty="0"/>
+              <a:t>El sistema ejecuta escenarios de prueba genéricos, como verificar la carga completa de la página o la ausencia de enlaces rotos.</a:t>
+            </a:r>
           </a:p>
         </p:txBody>
       </p:sp>
@@ -10205,27 +10274,8 @@
                 <a:ea typeface="Calibri" panose="020F0502020204030204" pitchFamily="34" charset="0"/>
                 <a:cs typeface="Times New Roman" panose="02020603050405020304" pitchFamily="18" charset="0"/>
               </a:rPr>
-              <a:t>El script navega hacia el módulo PIM (Personal </a:t>
-            </a:r>
-            <a:r>
-              <a:rPr lang="es-AR" sz="1600" dirty="0" err="1">
-                <a:effectLst/>
-                <a:latin typeface="Calibri" panose="020F0502020204030204" pitchFamily="34" charset="0"/>
-                <a:ea typeface="Calibri" panose="020F0502020204030204" pitchFamily="34" charset="0"/>
-                <a:cs typeface="Times New Roman" panose="02020603050405020304" pitchFamily="18" charset="0"/>
-              </a:rPr>
-              <a:t>Information</a:t>
-            </a:r>
-            <a:r>
-              <a:rPr lang="es-AR" sz="1600" dirty="0">
-                <a:effectLst/>
-                <a:latin typeface="Calibri" panose="020F0502020204030204" pitchFamily="34" charset="0"/>
-                <a:ea typeface="Calibri" panose="020F0502020204030204" pitchFamily="34" charset="0"/>
-                <a:cs typeface="Times New Roman" panose="02020603050405020304" pitchFamily="18" charset="0"/>
-              </a:rPr>
-              <a:t> Management) manejando los tiempos de carga asíncronos.</a:t>
-            </a:r>
-            <a:endParaRPr lang="es-CL" sz="1600" dirty="0"/>
+              <a:t>Las pruebas se adaptan a la cantidad de elementos encontrados, esperando a que la página esté completamente visible.</a:t>
+            </a:r>
           </a:p>
         </p:txBody>
       </p:sp>
@@ -10264,9 +10314,8 @@
                 <a:ea typeface="Calibri" panose="020F0502020204030204" pitchFamily="34" charset="0"/>
                 <a:cs typeface="Times New Roman" panose="02020603050405020304" pitchFamily="18" charset="0"/>
               </a:rPr>
-              <a:t>Se completa el formulario para crear un nuevo empleado con datos de pruebas estructurados.</a:t>
-            </a:r>
-            <a:endParaRPr lang="es-CL" sz="1600" dirty="0"/>
+              <a:t>Las pruebas se ejecutan de forma invisible y remota en la nube utilizando BrowserStack.</a:t>
+            </a:r>
           </a:p>
         </p:txBody>
       </p:sp>
@@ -10305,27 +10354,8 @@
                 <a:ea typeface="Calibri" panose="020F0502020204030204" pitchFamily="34" charset="0"/>
                 <a:cs typeface="Times New Roman" panose="02020603050405020304" pitchFamily="18" charset="0"/>
               </a:rPr>
-              <a:t>El sistema guarda el registro y valida que el mensaje de éxito se despliegue correctamente en el Front-</a:t>
-            </a:r>
-            <a:r>
-              <a:rPr lang="es-AR" sz="1600" dirty="0" err="1">
-                <a:effectLst/>
-                <a:latin typeface="Calibri" panose="020F0502020204030204" pitchFamily="34" charset="0"/>
-                <a:ea typeface="Calibri" panose="020F0502020204030204" pitchFamily="34" charset="0"/>
-                <a:cs typeface="Times New Roman" panose="02020603050405020304" pitchFamily="18" charset="0"/>
-              </a:rPr>
-              <a:t>End</a:t>
-            </a:r>
-            <a:r>
-              <a:rPr lang="es-AR" sz="1600" dirty="0">
-                <a:effectLst/>
-                <a:latin typeface="Calibri" panose="020F0502020204030204" pitchFamily="34" charset="0"/>
-                <a:ea typeface="Calibri" panose="020F0502020204030204" pitchFamily="34" charset="0"/>
-                <a:cs typeface="Times New Roman" panose="02020603050405020304" pitchFamily="18" charset="0"/>
-              </a:rPr>
-              <a:t>.</a:t>
-            </a:r>
-            <a:endParaRPr lang="es-CL" sz="1600" dirty="0"/>
+              <a:t>BrowserStack publica los resultados, videos y errores encontrados en su panel visual de diagnóstico.</a:t>
+            </a:r>
           </a:p>
         </p:txBody>
       </p:sp>
@@ -10364,81 +10394,8 @@
                 <a:ea typeface="Calibri" panose="020F0502020204030204" pitchFamily="34" charset="0"/>
                 <a:cs typeface="Times New Roman" panose="02020603050405020304" pitchFamily="18" charset="0"/>
               </a:rPr>
-              <a:t>Finalizada la prueba, </a:t>
-            </a:r>
-            <a:r>
-              <a:rPr lang="es-AR" sz="1600" dirty="0" err="1">
-                <a:effectLst/>
-                <a:latin typeface="Calibri" panose="020F0502020204030204" pitchFamily="34" charset="0"/>
-                <a:ea typeface="Calibri" panose="020F0502020204030204" pitchFamily="34" charset="0"/>
-                <a:cs typeface="Times New Roman" panose="02020603050405020304" pitchFamily="18" charset="0"/>
-              </a:rPr>
-              <a:t>Github</a:t>
-            </a:r>
-            <a:r>
-              <a:rPr lang="es-AR" sz="1600" dirty="0">
-                <a:effectLst/>
-                <a:latin typeface="Calibri" panose="020F0502020204030204" pitchFamily="34" charset="0"/>
-                <a:ea typeface="Calibri" panose="020F0502020204030204" pitchFamily="34" charset="0"/>
-                <a:cs typeface="Times New Roman" panose="02020603050405020304" pitchFamily="18" charset="0"/>
-              </a:rPr>
-              <a:t> </a:t>
-            </a:r>
-            <a:r>
-              <a:rPr lang="es-AR" sz="1600" dirty="0" err="1">
-                <a:effectLst/>
-                <a:latin typeface="Calibri" panose="020F0502020204030204" pitchFamily="34" charset="0"/>
-                <a:ea typeface="Calibri" panose="020F0502020204030204" pitchFamily="34" charset="0"/>
-                <a:cs typeface="Times New Roman" panose="02020603050405020304" pitchFamily="18" charset="0"/>
-              </a:rPr>
-              <a:t>Actions</a:t>
-            </a:r>
-            <a:r>
-              <a:rPr lang="es-AR" sz="1600" dirty="0">
-                <a:effectLst/>
-                <a:latin typeface="Calibri" panose="020F0502020204030204" pitchFamily="34" charset="0"/>
-                <a:ea typeface="Calibri" panose="020F0502020204030204" pitchFamily="34" charset="0"/>
-                <a:cs typeface="Times New Roman" panose="02020603050405020304" pitchFamily="18" charset="0"/>
-              </a:rPr>
-              <a:t> genera y publica un reporte visual con </a:t>
-            </a:r>
-            <a:r>
-              <a:rPr lang="es-AR" sz="1600" dirty="0" err="1">
-                <a:effectLst/>
-                <a:latin typeface="Calibri" panose="020F0502020204030204" pitchFamily="34" charset="0"/>
-                <a:ea typeface="Calibri" panose="020F0502020204030204" pitchFamily="34" charset="0"/>
-                <a:cs typeface="Times New Roman" panose="02020603050405020304" pitchFamily="18" charset="0"/>
-              </a:rPr>
-              <a:t>Allule</a:t>
-            </a:r>
-            <a:r>
-              <a:rPr lang="es-AR" sz="1600" dirty="0">
-                <a:effectLst/>
-                <a:latin typeface="Calibri" panose="020F0502020204030204" pitchFamily="34" charset="0"/>
-                <a:ea typeface="Calibri" panose="020F0502020204030204" pitchFamily="34" charset="0"/>
-                <a:cs typeface="Times New Roman" panose="02020603050405020304" pitchFamily="18" charset="0"/>
-              </a:rPr>
-              <a:t> </a:t>
-            </a:r>
-            <a:r>
-              <a:rPr lang="es-AR" sz="1600" dirty="0" err="1">
-                <a:effectLst/>
-                <a:latin typeface="Calibri" panose="020F0502020204030204" pitchFamily="34" charset="0"/>
-                <a:ea typeface="Calibri" panose="020F0502020204030204" pitchFamily="34" charset="0"/>
-                <a:cs typeface="Times New Roman" panose="02020603050405020304" pitchFamily="18" charset="0"/>
-              </a:rPr>
-              <a:t>reports</a:t>
-            </a:r>
-            <a:r>
-              <a:rPr lang="es-AR" sz="1600" dirty="0">
-                <a:effectLst/>
-                <a:latin typeface="Calibri" panose="020F0502020204030204" pitchFamily="34" charset="0"/>
-                <a:ea typeface="Calibri" panose="020F0502020204030204" pitchFamily="34" charset="0"/>
-                <a:cs typeface="Times New Roman" panose="02020603050405020304" pitchFamily="18" charset="0"/>
-              </a:rPr>
-              <a:t> detallando los resultados de la ejecución.</a:t>
-            </a:r>
-            <a:endParaRPr lang="es-CL" sz="1600" dirty="0"/>
+              <a:t>Al finalizar, el usuario recibe un enlace con el panel visual que detalla qué pruebas pasaron y cuáles fallaron.</a:t>
+            </a:r>
           </a:p>
         </p:txBody>
       </p:sp>
@@ -10680,10 +10637,10 @@
       </p:sp>
       <p:pic>
         <p:nvPicPr>
-          <p:cNvPr id="13" name="Imagen 12">
+          <p:cNvPr id="7" name="Imagen 6">
             <a:extLst>
               <a:ext uri="{FF2B5EF4-FFF2-40B4-BE49-F238E27FC236}">
-                <a16:creationId xmlns:a16="http://schemas.microsoft.com/office/drawing/2014/main" id="{E07C004D-C88F-4873-B74A-0343532BC604}"/>
+                <a16:creationId xmlns:a16="http://schemas.microsoft.com/office/drawing/2014/main" id="{841EE6E2-6EF3-4990-97D2-96CB3BCAE977}"/>
               </a:ext>
             </a:extLst>
           </p:cNvPr>
@@ -10700,632 +10657,14 @@
         </p:blipFill>
         <p:spPr>
           <a:xfrm>
-            <a:off x="811794" y="1330038"/>
-            <a:ext cx="2685985" cy="2390742"/>
+            <a:off x="1903445" y="1235909"/>
+            <a:ext cx="8285583" cy="5256331"/>
           </a:xfrm>
           <a:prstGeom prst="rect">
             <a:avLst/>
           </a:prstGeom>
         </p:spPr>
       </p:pic>
-      <p:sp>
-        <p:nvSpPr>
-          <p:cNvPr id="34" name="Shape 4">
-            <a:extLst>
-              <a:ext uri="{FF2B5EF4-FFF2-40B4-BE49-F238E27FC236}">
-                <a16:creationId xmlns:a16="http://schemas.microsoft.com/office/drawing/2014/main" id="{FBAB4A8F-D3D6-48EF-95C0-D980CAEEBD5E}"/>
-              </a:ext>
-            </a:extLst>
-          </p:cNvPr>
-          <p:cNvSpPr/>
-          <p:nvPr/>
-        </p:nvSpPr>
-        <p:spPr>
-          <a:xfrm>
-            <a:off x="641952" y="1328906"/>
-            <a:ext cx="457200" cy="457200"/>
-          </a:xfrm>
-          <a:prstGeom prst="ellipse">
-            <a:avLst/>
-          </a:prstGeom>
-          <a:solidFill>
-            <a:srgbClr val="1C7293"/>
-          </a:solidFill>
-          <a:ln/>
-        </p:spPr>
-        <p:txBody>
-          <a:bodyPr/>
-          <a:lstStyle/>
-          <a:p>
-            <a:endParaRPr lang="es-CL"/>
-          </a:p>
-        </p:txBody>
-      </p:sp>
-      <p:sp>
-        <p:nvSpPr>
-          <p:cNvPr id="35" name="Text 5">
-            <a:extLst>
-              <a:ext uri="{FF2B5EF4-FFF2-40B4-BE49-F238E27FC236}">
-                <a16:creationId xmlns:a16="http://schemas.microsoft.com/office/drawing/2014/main" id="{D7947831-F8EC-4897-8FC7-10F2A98CE473}"/>
-              </a:ext>
-            </a:extLst>
-          </p:cNvPr>
-          <p:cNvSpPr/>
-          <p:nvPr/>
-        </p:nvSpPr>
-        <p:spPr>
-          <a:xfrm>
-            <a:off x="640080" y="1319655"/>
-            <a:ext cx="457200" cy="457200"/>
-          </a:xfrm>
-          <a:prstGeom prst="rect">
-            <a:avLst/>
-          </a:prstGeom>
-          <a:noFill/>
-          <a:ln/>
-        </p:spPr>
-        <p:txBody>
-          <a:bodyPr wrap="square" rtlCol="0" anchor="ctr"/>
-          <a:lstStyle/>
-          <a:p>
-            <a:pPr marL="0" indent="0" algn="ctr">
-              <a:buNone/>
-            </a:pPr>
-            <a:r>
-              <a:rPr lang="en-US" sz="1500" b="1" dirty="0">
-                <a:solidFill>
-                  <a:srgbClr val="FFFFFF"/>
-                </a:solidFill>
-                <a:latin typeface="Cambria" pitchFamily="34" charset="0"/>
-                <a:ea typeface="Cambria" pitchFamily="34" charset="-122"/>
-                <a:cs typeface="Cambria" pitchFamily="34" charset="-120"/>
-              </a:rPr>
-              <a:t>1</a:t>
-            </a:r>
-            <a:endParaRPr lang="en-US" sz="1500" dirty="0"/>
-          </a:p>
-        </p:txBody>
-      </p:sp>
-      <p:pic>
-        <p:nvPicPr>
-          <p:cNvPr id="21" name="Imagen 20">
-            <a:extLst>
-              <a:ext uri="{FF2B5EF4-FFF2-40B4-BE49-F238E27FC236}">
-                <a16:creationId xmlns:a16="http://schemas.microsoft.com/office/drawing/2014/main" id="{A43F3DD4-06E8-4B82-9ED2-7AC0FE4F807E}"/>
-              </a:ext>
-            </a:extLst>
-          </p:cNvPr>
-          <p:cNvPicPr>
-            <a:picLocks noChangeAspect="1"/>
-          </p:cNvPicPr>
-          <p:nvPr/>
-        </p:nvPicPr>
-        <p:blipFill>
-          <a:blip r:embed="rId5"/>
-          <a:stretch>
-            <a:fillRect/>
-          </a:stretch>
-        </p:blipFill>
-        <p:spPr>
-          <a:xfrm>
-            <a:off x="4427154" y="1304795"/>
-            <a:ext cx="2570805" cy="2442856"/>
-          </a:xfrm>
-          <a:prstGeom prst="rect">
-            <a:avLst/>
-          </a:prstGeom>
-        </p:spPr>
-      </p:pic>
-      <p:sp>
-        <p:nvSpPr>
-          <p:cNvPr id="36" name="Shape 8">
-            <a:extLst>
-              <a:ext uri="{FF2B5EF4-FFF2-40B4-BE49-F238E27FC236}">
-                <a16:creationId xmlns:a16="http://schemas.microsoft.com/office/drawing/2014/main" id="{DA7373A1-ACEB-4919-833D-03AE3ACD566B}"/>
-              </a:ext>
-            </a:extLst>
-          </p:cNvPr>
-          <p:cNvSpPr/>
-          <p:nvPr/>
-        </p:nvSpPr>
-        <p:spPr>
-          <a:xfrm>
-            <a:off x="4252308" y="1299207"/>
-            <a:ext cx="457200" cy="457200"/>
-          </a:xfrm>
-          <a:prstGeom prst="ellipse">
-            <a:avLst/>
-          </a:prstGeom>
-          <a:solidFill>
-            <a:srgbClr val="1C7293"/>
-          </a:solidFill>
-          <a:ln/>
-        </p:spPr>
-        <p:txBody>
-          <a:bodyPr/>
-          <a:lstStyle/>
-          <a:p>
-            <a:endParaRPr lang="es-CL"/>
-          </a:p>
-        </p:txBody>
-      </p:sp>
-      <p:sp>
-        <p:nvSpPr>
-          <p:cNvPr id="37" name="Text 9">
-            <a:extLst>
-              <a:ext uri="{FF2B5EF4-FFF2-40B4-BE49-F238E27FC236}">
-                <a16:creationId xmlns:a16="http://schemas.microsoft.com/office/drawing/2014/main" id="{E1CD7768-92B3-417F-BE62-999CA746EDC5}"/>
-              </a:ext>
-            </a:extLst>
-          </p:cNvPr>
-          <p:cNvSpPr/>
-          <p:nvPr/>
-        </p:nvSpPr>
-        <p:spPr>
-          <a:xfrm>
-            <a:off x="4252308" y="1299207"/>
-            <a:ext cx="457200" cy="457200"/>
-          </a:xfrm>
-          <a:prstGeom prst="rect">
-            <a:avLst/>
-          </a:prstGeom>
-          <a:noFill/>
-          <a:ln/>
-        </p:spPr>
-        <p:txBody>
-          <a:bodyPr wrap="square" rtlCol="0" anchor="ctr"/>
-          <a:lstStyle/>
-          <a:p>
-            <a:pPr marL="0" indent="0" algn="ctr">
-              <a:buNone/>
-            </a:pPr>
-            <a:r>
-              <a:rPr lang="en-US" sz="1500" b="1" dirty="0">
-                <a:solidFill>
-                  <a:srgbClr val="FFFFFF"/>
-                </a:solidFill>
-                <a:latin typeface="Cambria" pitchFamily="34" charset="0"/>
-                <a:ea typeface="Cambria" pitchFamily="34" charset="-122"/>
-                <a:cs typeface="Cambria" pitchFamily="34" charset="-120"/>
-              </a:rPr>
-              <a:t>2</a:t>
-            </a:r>
-            <a:endParaRPr lang="en-US" sz="1500" dirty="0"/>
-          </a:p>
-        </p:txBody>
-      </p:sp>
-      <p:pic>
-        <p:nvPicPr>
-          <p:cNvPr id="29" name="Imagen 28">
-            <a:extLst>
-              <a:ext uri="{FF2B5EF4-FFF2-40B4-BE49-F238E27FC236}">
-                <a16:creationId xmlns:a16="http://schemas.microsoft.com/office/drawing/2014/main" id="{790CC6EC-78AA-4AD0-8F05-E3D07BF45085}"/>
-              </a:ext>
-            </a:extLst>
-          </p:cNvPr>
-          <p:cNvPicPr>
-            <a:picLocks noChangeAspect="1"/>
-          </p:cNvPicPr>
-          <p:nvPr/>
-        </p:nvPicPr>
-        <p:blipFill>
-          <a:blip r:embed="rId6"/>
-          <a:stretch>
-            <a:fillRect/>
-          </a:stretch>
-        </p:blipFill>
-        <p:spPr>
-          <a:xfrm>
-            <a:off x="8383230" y="1269496"/>
-            <a:ext cx="2891322" cy="2462777"/>
-          </a:xfrm>
-          <a:prstGeom prst="rect">
-            <a:avLst/>
-          </a:prstGeom>
-        </p:spPr>
-      </p:pic>
-      <p:sp>
-        <p:nvSpPr>
-          <p:cNvPr id="41" name="Shape 12">
-            <a:extLst>
-              <a:ext uri="{FF2B5EF4-FFF2-40B4-BE49-F238E27FC236}">
-                <a16:creationId xmlns:a16="http://schemas.microsoft.com/office/drawing/2014/main" id="{FA026C48-6C53-4B11-B03B-561319B23588}"/>
-              </a:ext>
-            </a:extLst>
-          </p:cNvPr>
-          <p:cNvSpPr/>
-          <p:nvPr/>
-        </p:nvSpPr>
-        <p:spPr>
-          <a:xfrm>
-            <a:off x="8321040" y="1310287"/>
-            <a:ext cx="457200" cy="457200"/>
-          </a:xfrm>
-          <a:prstGeom prst="ellipse">
-            <a:avLst/>
-          </a:prstGeom>
-          <a:solidFill>
-            <a:srgbClr val="1C7293"/>
-          </a:solidFill>
-          <a:ln/>
-        </p:spPr>
-        <p:txBody>
-          <a:bodyPr/>
-          <a:lstStyle/>
-          <a:p>
-            <a:endParaRPr lang="es-CL"/>
-          </a:p>
-        </p:txBody>
-      </p:sp>
-      <p:sp>
-        <p:nvSpPr>
-          <p:cNvPr id="42" name="Text 13">
-            <a:extLst>
-              <a:ext uri="{FF2B5EF4-FFF2-40B4-BE49-F238E27FC236}">
-                <a16:creationId xmlns:a16="http://schemas.microsoft.com/office/drawing/2014/main" id="{B63D5428-DA58-4D08-BDFA-6B1F8E583AC1}"/>
-              </a:ext>
-            </a:extLst>
-          </p:cNvPr>
-          <p:cNvSpPr/>
-          <p:nvPr/>
-        </p:nvSpPr>
-        <p:spPr>
-          <a:xfrm>
-            <a:off x="8321040" y="1310287"/>
-            <a:ext cx="457200" cy="457200"/>
-          </a:xfrm>
-          <a:prstGeom prst="rect">
-            <a:avLst/>
-          </a:prstGeom>
-          <a:noFill/>
-          <a:ln/>
-        </p:spPr>
-        <p:txBody>
-          <a:bodyPr wrap="square" rtlCol="0" anchor="ctr"/>
-          <a:lstStyle/>
-          <a:p>
-            <a:pPr marL="0" indent="0" algn="ctr">
-              <a:buNone/>
-            </a:pPr>
-            <a:r>
-              <a:rPr lang="en-US" sz="1500" b="1" dirty="0">
-                <a:solidFill>
-                  <a:srgbClr val="FFFFFF"/>
-                </a:solidFill>
-                <a:latin typeface="Cambria" pitchFamily="34" charset="0"/>
-                <a:ea typeface="Cambria" pitchFamily="34" charset="-122"/>
-                <a:cs typeface="Cambria" pitchFamily="34" charset="-120"/>
-              </a:rPr>
-              <a:t>3</a:t>
-            </a:r>
-            <a:endParaRPr lang="en-US" sz="1500" dirty="0"/>
-          </a:p>
-        </p:txBody>
-      </p:sp>
-      <p:pic>
-        <p:nvPicPr>
-          <p:cNvPr id="44" name="Imagen 43">
-            <a:extLst>
-              <a:ext uri="{FF2B5EF4-FFF2-40B4-BE49-F238E27FC236}">
-                <a16:creationId xmlns:a16="http://schemas.microsoft.com/office/drawing/2014/main" id="{0862A191-AD07-47CD-8697-58C1FC5852DB}"/>
-              </a:ext>
-            </a:extLst>
-          </p:cNvPr>
-          <p:cNvPicPr>
-            <a:picLocks noChangeAspect="1"/>
-          </p:cNvPicPr>
-          <p:nvPr/>
-        </p:nvPicPr>
-        <p:blipFill>
-          <a:blip r:embed="rId7"/>
-          <a:stretch>
-            <a:fillRect/>
-          </a:stretch>
-        </p:blipFill>
-        <p:spPr>
-          <a:xfrm>
-            <a:off x="4375839" y="3978469"/>
-            <a:ext cx="2822158" cy="2575219"/>
-          </a:xfrm>
-          <a:prstGeom prst="rect">
-            <a:avLst/>
-          </a:prstGeom>
-        </p:spPr>
-      </p:pic>
-      <p:sp>
-        <p:nvSpPr>
-          <p:cNvPr id="45" name="Shape 20">
-            <a:extLst>
-              <a:ext uri="{FF2B5EF4-FFF2-40B4-BE49-F238E27FC236}">
-                <a16:creationId xmlns:a16="http://schemas.microsoft.com/office/drawing/2014/main" id="{6D0FE479-8761-421F-8593-06930525F178}"/>
-              </a:ext>
-            </a:extLst>
-          </p:cNvPr>
-          <p:cNvSpPr/>
-          <p:nvPr/>
-        </p:nvSpPr>
-        <p:spPr>
-          <a:xfrm>
-            <a:off x="4198554" y="3977248"/>
-            <a:ext cx="457200" cy="457200"/>
-          </a:xfrm>
-          <a:prstGeom prst="ellipse">
-            <a:avLst/>
-          </a:prstGeom>
-          <a:solidFill>
-            <a:srgbClr val="1C7293"/>
-          </a:solidFill>
-          <a:ln/>
-        </p:spPr>
-        <p:txBody>
-          <a:bodyPr/>
-          <a:lstStyle/>
-          <a:p>
-            <a:endParaRPr lang="es-CL"/>
-          </a:p>
-        </p:txBody>
-      </p:sp>
-      <p:sp>
-        <p:nvSpPr>
-          <p:cNvPr id="46" name="Text 21">
-            <a:extLst>
-              <a:ext uri="{FF2B5EF4-FFF2-40B4-BE49-F238E27FC236}">
-                <a16:creationId xmlns:a16="http://schemas.microsoft.com/office/drawing/2014/main" id="{808A5564-D07E-4F0E-91AB-B02E69AC8FDC}"/>
-              </a:ext>
-            </a:extLst>
-          </p:cNvPr>
-          <p:cNvSpPr/>
-          <p:nvPr/>
-        </p:nvSpPr>
-        <p:spPr>
-          <a:xfrm>
-            <a:off x="4198554" y="3977248"/>
-            <a:ext cx="457200" cy="457200"/>
-          </a:xfrm>
-          <a:prstGeom prst="rect">
-            <a:avLst/>
-          </a:prstGeom>
-          <a:noFill/>
-          <a:ln/>
-        </p:spPr>
-        <p:txBody>
-          <a:bodyPr wrap="square" rtlCol="0" anchor="ctr"/>
-          <a:lstStyle/>
-          <a:p>
-            <a:pPr marL="0" indent="0" algn="ctr">
-              <a:buNone/>
-            </a:pPr>
-            <a:r>
-              <a:rPr lang="en-US" sz="1500" b="1" dirty="0">
-                <a:solidFill>
-                  <a:srgbClr val="FFFFFF"/>
-                </a:solidFill>
-                <a:latin typeface="Cambria" pitchFamily="34" charset="0"/>
-                <a:ea typeface="Cambria" pitchFamily="34" charset="-122"/>
-                <a:cs typeface="Cambria" pitchFamily="34" charset="-120"/>
-              </a:rPr>
-              <a:t>5</a:t>
-            </a:r>
-            <a:endParaRPr lang="en-US" sz="1500" dirty="0"/>
-          </a:p>
-        </p:txBody>
-      </p:sp>
-      <p:pic>
-        <p:nvPicPr>
-          <p:cNvPr id="48" name="Imagen 47">
-            <a:extLst>
-              <a:ext uri="{FF2B5EF4-FFF2-40B4-BE49-F238E27FC236}">
-                <a16:creationId xmlns:a16="http://schemas.microsoft.com/office/drawing/2014/main" id="{83D1311E-90B6-44B7-8258-26981389FFCD}"/>
-              </a:ext>
-            </a:extLst>
-          </p:cNvPr>
-          <p:cNvPicPr>
-            <a:picLocks noChangeAspect="1"/>
-          </p:cNvPicPr>
-          <p:nvPr/>
-        </p:nvPicPr>
-        <p:blipFill>
-          <a:blip r:embed="rId8"/>
-          <a:stretch>
-            <a:fillRect/>
-          </a:stretch>
-        </p:blipFill>
-        <p:spPr>
-          <a:xfrm>
-            <a:off x="8435952" y="3906527"/>
-            <a:ext cx="2748964" cy="2718038"/>
-          </a:xfrm>
-          <a:prstGeom prst="rect">
-            <a:avLst/>
-          </a:prstGeom>
-        </p:spPr>
-      </p:pic>
-      <p:sp>
-        <p:nvSpPr>
-          <p:cNvPr id="49" name="Shape 24">
-            <a:extLst>
-              <a:ext uri="{FF2B5EF4-FFF2-40B4-BE49-F238E27FC236}">
-                <a16:creationId xmlns:a16="http://schemas.microsoft.com/office/drawing/2014/main" id="{DB91E6AF-4F6F-4747-8D25-2C0C92871B11}"/>
-              </a:ext>
-            </a:extLst>
-          </p:cNvPr>
-          <p:cNvSpPr/>
-          <p:nvPr/>
-        </p:nvSpPr>
-        <p:spPr>
-          <a:xfrm>
-            <a:off x="8207352" y="3906527"/>
-            <a:ext cx="457200" cy="457200"/>
-          </a:xfrm>
-          <a:prstGeom prst="ellipse">
-            <a:avLst/>
-          </a:prstGeom>
-          <a:solidFill>
-            <a:srgbClr val="1C7293"/>
-          </a:solidFill>
-          <a:ln/>
-        </p:spPr>
-        <p:txBody>
-          <a:bodyPr/>
-          <a:lstStyle/>
-          <a:p>
-            <a:endParaRPr lang="es-CL"/>
-          </a:p>
-        </p:txBody>
-      </p:sp>
-      <p:sp>
-        <p:nvSpPr>
-          <p:cNvPr id="50" name="Text 25">
-            <a:extLst>
-              <a:ext uri="{FF2B5EF4-FFF2-40B4-BE49-F238E27FC236}">
-                <a16:creationId xmlns:a16="http://schemas.microsoft.com/office/drawing/2014/main" id="{A8644109-3A07-4749-B9E1-6D6A886B8A03}"/>
-              </a:ext>
-            </a:extLst>
-          </p:cNvPr>
-          <p:cNvSpPr/>
-          <p:nvPr/>
-        </p:nvSpPr>
-        <p:spPr>
-          <a:xfrm>
-            <a:off x="8207352" y="3906527"/>
-            <a:ext cx="457200" cy="457200"/>
-          </a:xfrm>
-          <a:prstGeom prst="rect">
-            <a:avLst/>
-          </a:prstGeom>
-          <a:noFill/>
-          <a:ln/>
-        </p:spPr>
-        <p:txBody>
-          <a:bodyPr wrap="square" rtlCol="0" anchor="ctr"/>
-          <a:lstStyle/>
-          <a:p>
-            <a:pPr marL="0" indent="0" algn="ctr">
-              <a:buNone/>
-            </a:pPr>
-            <a:r>
-              <a:rPr lang="en-US" sz="1500" b="1" dirty="0">
-                <a:solidFill>
-                  <a:srgbClr val="FFFFFF"/>
-                </a:solidFill>
-                <a:latin typeface="Cambria" pitchFamily="34" charset="0"/>
-                <a:ea typeface="Cambria" pitchFamily="34" charset="-122"/>
-                <a:cs typeface="Cambria" pitchFamily="34" charset="-120"/>
-              </a:rPr>
-              <a:t>6</a:t>
-            </a:r>
-            <a:endParaRPr lang="en-US" sz="1500" dirty="0"/>
-          </a:p>
-        </p:txBody>
-      </p:sp>
-      <p:pic>
-        <p:nvPicPr>
-          <p:cNvPr id="52" name="Imagen 51">
-            <a:extLst>
-              <a:ext uri="{FF2B5EF4-FFF2-40B4-BE49-F238E27FC236}">
-                <a16:creationId xmlns:a16="http://schemas.microsoft.com/office/drawing/2014/main" id="{435A0F4C-C352-40D6-8E17-AA59F9CCF159}"/>
-              </a:ext>
-            </a:extLst>
-          </p:cNvPr>
-          <p:cNvPicPr>
-            <a:picLocks noChangeAspect="1"/>
-          </p:cNvPicPr>
-          <p:nvPr/>
-        </p:nvPicPr>
-        <p:blipFill>
-          <a:blip r:embed="rId9"/>
-          <a:stretch>
-            <a:fillRect/>
-          </a:stretch>
-        </p:blipFill>
-        <p:spPr>
-          <a:xfrm>
-            <a:off x="893591" y="3978469"/>
-            <a:ext cx="2685985" cy="2586940"/>
-          </a:xfrm>
-          <a:prstGeom prst="rect">
-            <a:avLst/>
-          </a:prstGeom>
-        </p:spPr>
-      </p:pic>
-      <p:sp>
-        <p:nvSpPr>
-          <p:cNvPr id="53" name="Shape 16">
-            <a:extLst>
-              <a:ext uri="{FF2B5EF4-FFF2-40B4-BE49-F238E27FC236}">
-                <a16:creationId xmlns:a16="http://schemas.microsoft.com/office/drawing/2014/main" id="{42A17DDC-FBEA-472B-A518-55C5D9F50BB5}"/>
-              </a:ext>
-            </a:extLst>
-          </p:cNvPr>
-          <p:cNvSpPr/>
-          <p:nvPr/>
-        </p:nvSpPr>
-        <p:spPr>
-          <a:xfrm>
-            <a:off x="685800" y="3978469"/>
-            <a:ext cx="457200" cy="457200"/>
-          </a:xfrm>
-          <a:prstGeom prst="ellipse">
-            <a:avLst/>
-          </a:prstGeom>
-          <a:solidFill>
-            <a:srgbClr val="1C7293"/>
-          </a:solidFill>
-          <a:ln/>
-        </p:spPr>
-        <p:txBody>
-          <a:bodyPr/>
-          <a:lstStyle/>
-          <a:p>
-            <a:endParaRPr lang="es-CL"/>
-          </a:p>
-        </p:txBody>
-      </p:sp>
-      <p:sp>
-        <p:nvSpPr>
-          <p:cNvPr id="54" name="Text 17">
-            <a:extLst>
-              <a:ext uri="{FF2B5EF4-FFF2-40B4-BE49-F238E27FC236}">
-                <a16:creationId xmlns:a16="http://schemas.microsoft.com/office/drawing/2014/main" id="{2C181182-08CE-4684-8611-3F917E663E97}"/>
-              </a:ext>
-            </a:extLst>
-          </p:cNvPr>
-          <p:cNvSpPr/>
-          <p:nvPr/>
-        </p:nvSpPr>
-        <p:spPr>
-          <a:xfrm>
-            <a:off x="685800" y="3978469"/>
-            <a:ext cx="457200" cy="457200"/>
-          </a:xfrm>
-          <a:prstGeom prst="rect">
-            <a:avLst/>
-          </a:prstGeom>
-          <a:noFill/>
-          <a:ln/>
-        </p:spPr>
-        <p:txBody>
-          <a:bodyPr wrap="square" rtlCol="0" anchor="ctr"/>
-          <a:lstStyle/>
-          <a:p>
-            <a:pPr marL="0" indent="0" algn="ctr">
-              <a:buNone/>
-            </a:pPr>
-            <a:r>
-              <a:rPr lang="en-US" sz="1500" b="1" dirty="0">
-                <a:solidFill>
-                  <a:srgbClr val="FFFFFF"/>
-                </a:solidFill>
-                <a:latin typeface="Cambria" pitchFamily="34" charset="0"/>
-                <a:ea typeface="Cambria" pitchFamily="34" charset="-122"/>
-                <a:cs typeface="Cambria" pitchFamily="34" charset="-120"/>
-              </a:rPr>
-              <a:t>4</a:t>
-            </a:r>
-            <a:endParaRPr lang="en-US" sz="1500" dirty="0"/>
-          </a:p>
-        </p:txBody>
-      </p:sp>
     </p:spTree>
     <p:extLst>
       <p:ext uri="{BB962C8B-B14F-4D97-AF65-F5344CB8AC3E}">
@@ -11486,14 +10825,14 @@
       </p:sp>
       <p:sp>
         <p:nvSpPr>
-          <p:cNvPr id="6" name="Shape 3"/>
+          <p:cNvPr id="100" name="Shape C0"/>
           <p:cNvSpPr/>
           <p:nvPr/>
         </p:nvSpPr>
         <p:spPr>
           <a:xfrm>
             <a:off x="457200" y="1600200"/>
-            <a:ext cx="5500116" cy="1737360"/>
+            <a:ext cx="3605784" cy="1737360"/>
           </a:xfrm>
           <a:prstGeom prst="roundRect">
             <a:avLst>
@@ -11520,7 +10859,7 @@
       </p:sp>
       <p:sp>
         <p:nvSpPr>
-          <p:cNvPr id="7" name="Shape 4"/>
+          <p:cNvPr id="101" name="Shape Cir0"/>
           <p:cNvSpPr/>
           <p:nvPr/>
         </p:nvSpPr>
@@ -11547,7 +10886,7 @@
       </p:sp>
       <p:sp>
         <p:nvSpPr>
-          <p:cNvPr id="8" name="Text 5"/>
+          <p:cNvPr id="102" name="Text Num0"/>
           <p:cNvSpPr/>
           <p:nvPr/>
         </p:nvSpPr>
@@ -11586,14 +10925,14 @@
       </p:sp>
       <p:sp>
         <p:nvSpPr>
-          <p:cNvPr id="9" name="Text 6"/>
+          <p:cNvPr id="103" name="Text Title0"/>
           <p:cNvSpPr/>
           <p:nvPr/>
         </p:nvSpPr>
         <p:spPr>
           <a:xfrm>
             <a:off x="1371600" y="1801368"/>
-            <a:ext cx="4311396" cy="594360"/>
+            <a:ext cx="2417064" cy="594360"/>
           </a:xfrm>
           <a:prstGeom prst="rect">
             <a:avLst/>
@@ -11609,7 +10948,7 @@
               <a:buNone/>
             </a:pPr>
             <a:r>
-              <a:rPr lang="en-US" sz="2000" b="1" dirty="0">
+              <a:rPr lang="en-US" sz="1500" b="1" dirty="0">
                 <a:solidFill>
                   <a:srgbClr val="21295C"/>
                 </a:solidFill>
@@ -11617,22 +10956,22 @@
                 <a:ea typeface="Cambria" pitchFamily="34" charset="-122"/>
                 <a:cs typeface="Cambria" pitchFamily="34" charset="-120"/>
               </a:rPr>
-              <a:t>EP-001 · Arquitectura Base y POM</a:t>
-            </a:r>
-            <a:endParaRPr lang="en-US" sz="2000" dirty="0"/>
-          </a:p>
-        </p:txBody>
-      </p:sp>
-      <p:sp>
-        <p:nvSpPr>
-          <p:cNvPr id="10" name="Text 7"/>
+              <a:t>EP-001 · Configuración Inicial</a:t>
+            </a:r>
+            <a:endParaRPr lang="en-US" sz="1500" dirty="0"/>
+          </a:p>
+        </p:txBody>
+      </p:sp>
+      <p:sp>
+        <p:nvSpPr>
+          <p:cNvPr id="104" name="Text Desc0"/>
           <p:cNvSpPr/>
           <p:nvPr/>
         </p:nvSpPr>
         <p:spPr>
           <a:xfrm>
             <a:off x="713232" y="2560320"/>
-            <a:ext cx="4988052" cy="685800"/>
+            <a:ext cx="3093720" cy="685800"/>
           </a:xfrm>
           <a:prstGeom prst="rect">
             <a:avLst/>
@@ -11648,7 +10987,7 @@
               <a:buNone/>
             </a:pPr>
             <a:r>
-              <a:rPr lang="en-US" dirty="0">
+              <a:rPr lang="en-US" sz="1200" dirty="0">
                 <a:solidFill>
                   <a:srgbClr val="5B6B79"/>
                 </a:solidFill>
@@ -11656,7 +10995,7 @@
                 <a:ea typeface="Calibri" pitchFamily="34" charset="-122"/>
                 <a:cs typeface="Calibri" pitchFamily="34" charset="-120"/>
               </a:rPr>
-              <a:t>Estructura del framework y patrón Page Object Model</a:t>
+              <a:t>Instalación simple: solo se requiere la URL</a:t>
             </a:r>
             <a:endParaRPr lang="en-US" dirty="0"/>
           </a:p>
@@ -11664,14 +11003,14 @@
       </p:sp>
       <p:sp>
         <p:nvSpPr>
-          <p:cNvPr id="11" name="Shape 8"/>
-          <p:cNvSpPr/>
-          <p:nvPr/>
-        </p:nvSpPr>
-        <p:spPr>
-          <a:xfrm>
-            <a:off x="6231636" y="1600200"/>
-            <a:ext cx="5500116" cy="1737360"/>
+          <p:cNvPr id="110" name="Shape C1"/>
+          <p:cNvSpPr/>
+          <p:nvPr/>
+        </p:nvSpPr>
+        <p:spPr>
+          <a:xfrm>
+            <a:off x="4291584" y="1600200"/>
+            <a:ext cx="3605784" cy="1737360"/>
           </a:xfrm>
           <a:prstGeom prst="roundRect">
             <a:avLst>
@@ -11698,13 +11037,13 @@
       </p:sp>
       <p:sp>
         <p:nvSpPr>
-          <p:cNvPr id="12" name="Shape 9"/>
-          <p:cNvSpPr/>
-          <p:nvPr/>
-        </p:nvSpPr>
-        <p:spPr>
-          <a:xfrm>
-            <a:off x="6487668" y="1856232"/>
+          <p:cNvPr id="111" name="Shape Cir1"/>
+          <p:cNvSpPr/>
+          <p:nvPr/>
+        </p:nvSpPr>
+        <p:spPr>
+          <a:xfrm>
+            <a:off x="4547616" y="1856232"/>
             <a:ext cx="502920" cy="502920"/>
           </a:xfrm>
           <a:prstGeom prst="ellipse">
@@ -11725,13 +11064,13 @@
       </p:sp>
       <p:sp>
         <p:nvSpPr>
-          <p:cNvPr id="13" name="Text 10"/>
-          <p:cNvSpPr/>
-          <p:nvPr/>
-        </p:nvSpPr>
-        <p:spPr>
-          <a:xfrm>
-            <a:off x="6487668" y="1856232"/>
+          <p:cNvPr id="112" name="Text Num1"/>
+          <p:cNvSpPr/>
+          <p:nvPr/>
+        </p:nvSpPr>
+        <p:spPr>
+          <a:xfrm>
+            <a:off x="4547616" y="1856232"/>
             <a:ext cx="502920" cy="502920"/>
           </a:xfrm>
           <a:prstGeom prst="rect">
@@ -11764,14 +11103,14 @@
       </p:sp>
       <p:sp>
         <p:nvSpPr>
-          <p:cNvPr id="14" name="Text 11"/>
-          <p:cNvSpPr/>
-          <p:nvPr/>
-        </p:nvSpPr>
-        <p:spPr>
-          <a:xfrm>
-            <a:off x="7146036" y="1801368"/>
-            <a:ext cx="4311396" cy="594360"/>
+          <p:cNvPr id="113" name="Text Title1"/>
+          <p:cNvSpPr/>
+          <p:nvPr/>
+        </p:nvSpPr>
+        <p:spPr>
+          <a:xfrm>
+            <a:off x="5205984" y="1801368"/>
+            <a:ext cx="2417064" cy="594360"/>
           </a:xfrm>
           <a:prstGeom prst="rect">
             <a:avLst/>
@@ -11787,7 +11126,7 @@
               <a:buNone/>
             </a:pPr>
             <a:r>
-              <a:rPr lang="en-US" sz="2000" b="1" dirty="0">
+              <a:rPr lang="en-US" sz="1500" b="1" dirty="0">
                 <a:solidFill>
                   <a:srgbClr val="21295C"/>
                 </a:solidFill>
@@ -11795,22 +11134,22 @@
                 <a:ea typeface="Cambria" pitchFamily="34" charset="-122"/>
                 <a:cs typeface="Cambria" pitchFamily="34" charset="-120"/>
               </a:rPr>
-              <a:t>EP-002 · Automatización Flujos UI</a:t>
-            </a:r>
-            <a:endParaRPr lang="en-US" sz="2000" dirty="0"/>
-          </a:p>
-        </p:txBody>
-      </p:sp>
-      <p:sp>
-        <p:nvSpPr>
-          <p:cNvPr id="15" name="Text 12"/>
-          <p:cNvSpPr/>
-          <p:nvPr/>
-        </p:nvSpPr>
-        <p:spPr>
-          <a:xfrm>
-            <a:off x="6487668" y="2560320"/>
-            <a:ext cx="4988052" cy="685800"/>
+              <a:t>EP-002 · Escaneo Automático</a:t>
+            </a:r>
+            <a:endParaRPr lang="en-US" sz="1500" dirty="0"/>
+          </a:p>
+        </p:txBody>
+      </p:sp>
+      <p:sp>
+        <p:nvSpPr>
+          <p:cNvPr id="114" name="Text Desc1"/>
+          <p:cNvSpPr/>
+          <p:nvPr/>
+        </p:nvSpPr>
+        <p:spPr>
+          <a:xfrm>
+            <a:off x="4547616" y="2560320"/>
+            <a:ext cx="3093720" cy="685800"/>
           </a:xfrm>
           <a:prstGeom prst="rect">
             <a:avLst/>
@@ -11826,7 +11165,7 @@
               <a:buNone/>
             </a:pPr>
             <a:r>
-              <a:rPr lang="en-US" dirty="0">
+              <a:rPr lang="en-US" sz="1200" dirty="0">
                 <a:solidFill>
                   <a:srgbClr val="5B6B79"/>
                 </a:solidFill>
@@ -11834,7 +11173,7 @@
                 <a:ea typeface="Calibri" pitchFamily="34" charset="-122"/>
                 <a:cs typeface="Calibri" pitchFamily="34" charset="-120"/>
               </a:rPr>
-              <a:t>Pruebas de flujos transaccionales críticos de Front-End</a:t>
+              <a:t>Identifica enlaces, imágenes y botones</a:t>
             </a:r>
             <a:endParaRPr lang="en-US" dirty="0"/>
           </a:p>
@@ -11842,14 +11181,14 @@
       </p:sp>
       <p:sp>
         <p:nvSpPr>
-          <p:cNvPr id="16" name="Shape 13"/>
-          <p:cNvSpPr/>
-          <p:nvPr/>
-        </p:nvSpPr>
-        <p:spPr>
-          <a:xfrm>
-            <a:off x="457200" y="3657600"/>
-            <a:ext cx="5500116" cy="1737360"/>
+          <p:cNvPr id="120" name="Shape C2"/>
+          <p:cNvSpPr/>
+          <p:nvPr/>
+        </p:nvSpPr>
+        <p:spPr>
+          <a:xfrm>
+            <a:off x="8125968" y="1600200"/>
+            <a:ext cx="3605784" cy="1737360"/>
           </a:xfrm>
           <a:prstGeom prst="roundRect">
             <a:avLst>
@@ -11876,13 +11215,13 @@
       </p:sp>
       <p:sp>
         <p:nvSpPr>
-          <p:cNvPr id="17" name="Shape 14"/>
-          <p:cNvSpPr/>
-          <p:nvPr/>
-        </p:nvSpPr>
-        <p:spPr>
-          <a:xfrm>
-            <a:off x="713232" y="3913632"/>
+          <p:cNvPr id="121" name="Shape Cir2"/>
+          <p:cNvSpPr/>
+          <p:nvPr/>
+        </p:nvSpPr>
+        <p:spPr>
+          <a:xfrm>
+            <a:off x="8382000" y="1856232"/>
             <a:ext cx="502920" cy="502920"/>
           </a:xfrm>
           <a:prstGeom prst="ellipse">
@@ -11903,13 +11242,13 @@
       </p:sp>
       <p:sp>
         <p:nvSpPr>
-          <p:cNvPr id="18" name="Text 15"/>
-          <p:cNvSpPr/>
-          <p:nvPr/>
-        </p:nvSpPr>
-        <p:spPr>
-          <a:xfrm>
-            <a:off x="713232" y="3913632"/>
+          <p:cNvPr id="122" name="Text Num2"/>
+          <p:cNvSpPr/>
+          <p:nvPr/>
+        </p:nvSpPr>
+        <p:spPr>
+          <a:xfrm>
+            <a:off x="8382000" y="1856232"/>
             <a:ext cx="502920" cy="502920"/>
           </a:xfrm>
           <a:prstGeom prst="rect">
@@ -11942,14 +11281,14 @@
       </p:sp>
       <p:sp>
         <p:nvSpPr>
-          <p:cNvPr id="19" name="Text 16"/>
-          <p:cNvSpPr/>
-          <p:nvPr/>
-        </p:nvSpPr>
-        <p:spPr>
-          <a:xfrm>
-            <a:off x="1371600" y="3858768"/>
-            <a:ext cx="4311396" cy="594360"/>
+          <p:cNvPr id="123" name="Text Title2"/>
+          <p:cNvSpPr/>
+          <p:nvPr/>
+        </p:nvSpPr>
+        <p:spPr>
+          <a:xfrm>
+            <a:off x="9040368" y="1801368"/>
+            <a:ext cx="2417064" cy="594360"/>
           </a:xfrm>
           <a:prstGeom prst="rect">
             <a:avLst/>
@@ -11965,7 +11304,7 @@
               <a:buNone/>
             </a:pPr>
             <a:r>
-              <a:rPr lang="en-US" sz="2000" b="1" dirty="0">
+              <a:rPr lang="en-US" sz="1500" b="1" dirty="0">
                 <a:solidFill>
                   <a:srgbClr val="21295C"/>
                 </a:solidFill>
@@ -11973,22 +11312,22 @@
                 <a:ea typeface="Cambria" pitchFamily="34" charset="-122"/>
                 <a:cs typeface="Cambria" pitchFamily="34" charset="-120"/>
               </a:rPr>
-              <a:t>EP-003 · Integración Cloud</a:t>
-            </a:r>
-            <a:endParaRPr lang="en-US" sz="2000" dirty="0"/>
-          </a:p>
-        </p:txBody>
-      </p:sp>
-      <p:sp>
-        <p:nvSpPr>
-          <p:cNvPr id="20" name="Text 17"/>
-          <p:cNvSpPr/>
-          <p:nvPr/>
-        </p:nvSpPr>
-        <p:spPr>
-          <a:xfrm>
-            <a:off x="713232" y="4617720"/>
-            <a:ext cx="4988052" cy="685800"/>
+              <a:t>EP-003 · Escenarios Genéricos</a:t>
+            </a:r>
+            <a:endParaRPr lang="en-US" sz="1500" dirty="0"/>
+          </a:p>
+        </p:txBody>
+      </p:sp>
+      <p:sp>
+        <p:nvSpPr>
+          <p:cNvPr id="124" name="Text Desc2"/>
+          <p:cNvSpPr/>
+          <p:nvPr/>
+        </p:nvSpPr>
+        <p:spPr>
+          <a:xfrm>
+            <a:off x="8382000" y="2560320"/>
+            <a:ext cx="3093720" cy="685800"/>
           </a:xfrm>
           <a:prstGeom prst="rect">
             <a:avLst/>
@@ -12004,7 +11343,7 @@
               <a:buNone/>
             </a:pPr>
             <a:r>
-              <a:rPr lang="en-US" dirty="0">
+              <a:rPr lang="en-US" sz="1200" dirty="0">
                 <a:solidFill>
                   <a:srgbClr val="5B6B79"/>
                 </a:solidFill>
@@ -12012,7 +11351,7 @@
                 <a:ea typeface="Calibri" pitchFamily="34" charset="-122"/>
                 <a:cs typeface="Calibri" pitchFamily="34" charset="-120"/>
               </a:rPr>
-              <a:t>Orquestación con BrowserStack Automate</a:t>
+              <a:t>Reglas universales en lenguaje natural</a:t>
             </a:r>
             <a:endParaRPr lang="en-US" dirty="0"/>
           </a:p>
@@ -12020,14 +11359,14 @@
       </p:sp>
       <p:sp>
         <p:nvSpPr>
-          <p:cNvPr id="21" name="Shape 18"/>
-          <p:cNvSpPr/>
-          <p:nvPr/>
-        </p:nvSpPr>
-        <p:spPr>
-          <a:xfrm>
-            <a:off x="6231636" y="3657600"/>
-            <a:ext cx="5500116" cy="1737360"/>
+          <p:cNvPr id="130" name="Shape C3"/>
+          <p:cNvSpPr/>
+          <p:nvPr/>
+        </p:nvSpPr>
+        <p:spPr>
+          <a:xfrm>
+            <a:off x="457200" y="3657600"/>
+            <a:ext cx="3605784" cy="1737360"/>
           </a:xfrm>
           <a:prstGeom prst="roundRect">
             <a:avLst>
@@ -12054,13 +11393,13 @@
       </p:sp>
       <p:sp>
         <p:nvSpPr>
-          <p:cNvPr id="22" name="Shape 19"/>
-          <p:cNvSpPr/>
-          <p:nvPr/>
-        </p:nvSpPr>
-        <p:spPr>
-          <a:xfrm>
-            <a:off x="6487668" y="3913632"/>
+          <p:cNvPr id="131" name="Shape Cir3"/>
+          <p:cNvSpPr/>
+          <p:nvPr/>
+        </p:nvSpPr>
+        <p:spPr>
+          <a:xfrm>
+            <a:off x="713232" y="3913632"/>
             <a:ext cx="502920" cy="502920"/>
           </a:xfrm>
           <a:prstGeom prst="ellipse">
@@ -12081,13 +11420,13 @@
       </p:sp>
       <p:sp>
         <p:nvSpPr>
-          <p:cNvPr id="23" name="Text 20"/>
-          <p:cNvSpPr/>
-          <p:nvPr/>
-        </p:nvSpPr>
-        <p:spPr>
-          <a:xfrm>
-            <a:off x="6487668" y="3913632"/>
+          <p:cNvPr id="132" name="Text Num3"/>
+          <p:cNvSpPr/>
+          <p:nvPr/>
+        </p:nvSpPr>
+        <p:spPr>
+          <a:xfrm>
+            <a:off x="713232" y="3913632"/>
             <a:ext cx="502920" cy="502920"/>
           </a:xfrm>
           <a:prstGeom prst="rect">
@@ -12120,14 +11459,14 @@
       </p:sp>
       <p:sp>
         <p:nvSpPr>
-          <p:cNvPr id="24" name="Text 21"/>
-          <p:cNvSpPr/>
-          <p:nvPr/>
-        </p:nvSpPr>
-        <p:spPr>
-          <a:xfrm>
-            <a:off x="7146036" y="3858768"/>
-            <a:ext cx="4311396" cy="594360"/>
+          <p:cNvPr id="133" name="Text Title3"/>
+          <p:cNvSpPr/>
+          <p:nvPr/>
+        </p:nvSpPr>
+        <p:spPr>
+          <a:xfrm>
+            <a:off x="1371600" y="3858768"/>
+            <a:ext cx="2417064" cy="594360"/>
           </a:xfrm>
           <a:prstGeom prst="rect">
             <a:avLst/>
@@ -12143,7 +11482,7 @@
               <a:buNone/>
             </a:pPr>
             <a:r>
-              <a:rPr lang="en-US" sz="2000" b="1" dirty="0">
+              <a:rPr lang="en-US" sz="1500" b="1" dirty="0">
                 <a:solidFill>
                   <a:srgbClr val="21295C"/>
                 </a:solidFill>
@@ -12151,22 +11490,22 @@
                 <a:ea typeface="Cambria" pitchFamily="34" charset="-122"/>
                 <a:cs typeface="Cambria" pitchFamily="34" charset="-120"/>
               </a:rPr>
-              <a:t>EP-004 · Dashboard y Telemetría</a:t>
-            </a:r>
-            <a:endParaRPr lang="en-US" sz="2000" dirty="0"/>
-          </a:p>
-        </p:txBody>
-      </p:sp>
-      <p:sp>
-        <p:nvSpPr>
-          <p:cNvPr id="25" name="Text 22"/>
-          <p:cNvSpPr/>
-          <p:nvPr/>
-        </p:nvSpPr>
-        <p:spPr>
-          <a:xfrm>
-            <a:off x="6487668" y="4617720"/>
-            <a:ext cx="4988052" cy="685800"/>
+              <a:t>EP-004 · Adaptabilidad Dinámica</a:t>
+            </a:r>
+            <a:endParaRPr lang="en-US" sz="1500" dirty="0"/>
+          </a:p>
+        </p:txBody>
+      </p:sp>
+      <p:sp>
+        <p:nvSpPr>
+          <p:cNvPr id="134" name="Text Desc3"/>
+          <p:cNvSpPr/>
+          <p:nvPr/>
+        </p:nvSpPr>
+        <p:spPr>
+          <a:xfrm>
+            <a:off x="713232" y="4617720"/>
+            <a:ext cx="3093720" cy="685800"/>
           </a:xfrm>
           <a:prstGeom prst="rect">
             <a:avLst/>
@@ -12182,7 +11521,7 @@
               <a:buNone/>
             </a:pPr>
             <a:r>
-              <a:rPr lang="en-US" dirty="0">
+              <a:rPr lang="en-US" sz="1200" dirty="0">
                 <a:solidFill>
                   <a:srgbClr val="5B6B79"/>
                 </a:solidFill>
@@ -12190,7 +11529,363 @@
                 <a:ea typeface="Calibri" pitchFamily="34" charset="-122"/>
                 <a:cs typeface="Calibri" pitchFamily="34" charset="-120"/>
               </a:rPr>
-              <a:t>Monitoreo, métricas y reportabilidad</a:t>
+              <a:t>Se ajusta a la cantidad de elementos hallados</a:t>
+            </a:r>
+            <a:endParaRPr lang="en-US" dirty="0"/>
+          </a:p>
+        </p:txBody>
+      </p:sp>
+      <p:sp>
+        <p:nvSpPr>
+          <p:cNvPr id="140" name="Shape C4"/>
+          <p:cNvSpPr/>
+          <p:nvPr/>
+        </p:nvSpPr>
+        <p:spPr>
+          <a:xfrm>
+            <a:off x="4291584" y="3657600"/>
+            <a:ext cx="3605784" cy="1737360"/>
+          </a:xfrm>
+          <a:prstGeom prst="roundRect">
+            <a:avLst>
+              <a:gd name="adj" fmla="val 6316"/>
+            </a:avLst>
+          </a:prstGeom>
+          <a:solidFill>
+            <a:srgbClr val="FFFFFF"/>
+          </a:solidFill>
+          <a:ln w="12700">
+            <a:solidFill>
+              <a:srgbClr val="E1E8EC"/>
+            </a:solidFill>
+            <a:prstDash val="solid"/>
+          </a:ln>
+        </p:spPr>
+        <p:txBody>
+          <a:bodyPr/>
+          <a:lstStyle/>
+          <a:p>
+            <a:endParaRPr lang="es-CL"/>
+          </a:p>
+        </p:txBody>
+      </p:sp>
+      <p:sp>
+        <p:nvSpPr>
+          <p:cNvPr id="141" name="Shape Cir4"/>
+          <p:cNvSpPr/>
+          <p:nvPr/>
+        </p:nvSpPr>
+        <p:spPr>
+          <a:xfrm>
+            <a:off x="4547616" y="3913632"/>
+            <a:ext cx="502920" cy="502920"/>
+          </a:xfrm>
+          <a:prstGeom prst="ellipse">
+            <a:avLst/>
+          </a:prstGeom>
+          <a:solidFill>
+            <a:srgbClr val="065A82"/>
+          </a:solidFill>
+          <a:ln/>
+        </p:spPr>
+        <p:txBody>
+          <a:bodyPr/>
+          <a:lstStyle/>
+          <a:p>
+            <a:endParaRPr lang="es-CL"/>
+          </a:p>
+        </p:txBody>
+      </p:sp>
+      <p:sp>
+        <p:nvSpPr>
+          <p:cNvPr id="142" name="Text Num4"/>
+          <p:cNvSpPr/>
+          <p:nvPr/>
+        </p:nvSpPr>
+        <p:spPr>
+          <a:xfrm>
+            <a:off x="4547616" y="3913632"/>
+            <a:ext cx="502920" cy="502920"/>
+          </a:xfrm>
+          <a:prstGeom prst="rect">
+            <a:avLst/>
+          </a:prstGeom>
+          <a:noFill/>
+          <a:ln/>
+        </p:spPr>
+        <p:txBody>
+          <a:bodyPr wrap="square" rtlCol="0" anchor="ctr"/>
+          <a:lstStyle/>
+          <a:p>
+            <a:pPr marL="0" indent="0" algn="ctr">
+              <a:buNone/>
+            </a:pPr>
+            <a:r>
+              <a:rPr lang="en-US" sz="1300" b="1" dirty="0">
+                <a:solidFill>
+                  <a:srgbClr val="FFFFFF"/>
+                </a:solidFill>
+                <a:latin typeface="Cambria" pitchFamily="34" charset="0"/>
+                <a:ea typeface="Cambria" pitchFamily="34" charset="-122"/>
+                <a:cs typeface="Cambria" pitchFamily="34" charset="-120"/>
+              </a:rPr>
+              <a:t>05</a:t>
+            </a:r>
+            <a:endParaRPr lang="en-US" sz="1300" dirty="0"/>
+          </a:p>
+        </p:txBody>
+      </p:sp>
+      <p:sp>
+        <p:nvSpPr>
+          <p:cNvPr id="143" name="Text Title4"/>
+          <p:cNvSpPr/>
+          <p:nvPr/>
+        </p:nvSpPr>
+        <p:spPr>
+          <a:xfrm>
+            <a:off x="5205984" y="3858768"/>
+            <a:ext cx="2417064" cy="594360"/>
+          </a:xfrm>
+          <a:prstGeom prst="rect">
+            <a:avLst/>
+          </a:prstGeom>
+          <a:noFill/>
+          <a:ln/>
+        </p:spPr>
+        <p:txBody>
+          <a:bodyPr wrap="square" rtlCol="0" anchor="ctr"/>
+          <a:lstStyle/>
+          <a:p>
+            <a:pPr marL="0" indent="0" algn="l">
+              <a:buNone/>
+            </a:pPr>
+            <a:r>
+              <a:rPr lang="en-US" sz="1500" b="1" dirty="0">
+                <a:solidFill>
+                  <a:srgbClr val="21295C"/>
+                </a:solidFill>
+                <a:latin typeface="Cambria" pitchFamily="34" charset="0"/>
+                <a:ea typeface="Cambria" pitchFamily="34" charset="-122"/>
+                <a:cs typeface="Cambria" pitchFamily="34" charset="-120"/>
+              </a:rPr>
+              <a:t>EP-005 · Ejecución en la Nube</a:t>
+            </a:r>
+            <a:endParaRPr lang="en-US" sz="1500" dirty="0"/>
+          </a:p>
+        </p:txBody>
+      </p:sp>
+      <p:sp>
+        <p:nvSpPr>
+          <p:cNvPr id="144" name="Text Desc4"/>
+          <p:cNvSpPr/>
+          <p:nvPr/>
+        </p:nvSpPr>
+        <p:spPr>
+          <a:xfrm>
+            <a:off x="4547616" y="4617720"/>
+            <a:ext cx="3093720" cy="685800"/>
+          </a:xfrm>
+          <a:prstGeom prst="rect">
+            <a:avLst/>
+          </a:prstGeom>
+          <a:noFill/>
+          <a:ln/>
+        </p:spPr>
+        <p:txBody>
+          <a:bodyPr wrap="square" rtlCol="0" anchor="ctr"/>
+          <a:lstStyle/>
+          <a:p>
+            <a:pPr marL="0" indent="0" algn="l">
+              <a:buNone/>
+            </a:pPr>
+            <a:r>
+              <a:rPr lang="en-US" sz="1200" dirty="0">
+                <a:solidFill>
+                  <a:srgbClr val="5B6B79"/>
+                </a:solidFill>
+                <a:latin typeface="Calibri" pitchFamily="34" charset="0"/>
+                <a:ea typeface="Calibri" pitchFamily="34" charset="-122"/>
+                <a:cs typeface="Calibri" pitchFamily="34" charset="-120"/>
+              </a:rPr>
+              <a:t>Pruebas en BrowserStack, multi-navegador</a:t>
+            </a:r>
+            <a:endParaRPr lang="en-US" dirty="0"/>
+          </a:p>
+        </p:txBody>
+      </p:sp>
+      <p:sp>
+        <p:nvSpPr>
+          <p:cNvPr id="150" name="Shape C5"/>
+          <p:cNvSpPr/>
+          <p:nvPr/>
+        </p:nvSpPr>
+        <p:spPr>
+          <a:xfrm>
+            <a:off x="8125968" y="3657600"/>
+            <a:ext cx="3605784" cy="1737360"/>
+          </a:xfrm>
+          <a:prstGeom prst="roundRect">
+            <a:avLst>
+              <a:gd name="adj" fmla="val 6316"/>
+            </a:avLst>
+          </a:prstGeom>
+          <a:solidFill>
+            <a:srgbClr val="FFFFFF"/>
+          </a:solidFill>
+          <a:ln w="12700">
+            <a:solidFill>
+              <a:srgbClr val="E1E8EC"/>
+            </a:solidFill>
+            <a:prstDash val="solid"/>
+          </a:ln>
+        </p:spPr>
+        <p:txBody>
+          <a:bodyPr/>
+          <a:lstStyle/>
+          <a:p>
+            <a:endParaRPr lang="es-CL"/>
+          </a:p>
+        </p:txBody>
+      </p:sp>
+      <p:sp>
+        <p:nvSpPr>
+          <p:cNvPr id="151" name="Shape Cir5"/>
+          <p:cNvSpPr/>
+          <p:nvPr/>
+        </p:nvSpPr>
+        <p:spPr>
+          <a:xfrm>
+            <a:off x="8382000" y="3913632"/>
+            <a:ext cx="502920" cy="502920"/>
+          </a:xfrm>
+          <a:prstGeom prst="ellipse">
+            <a:avLst/>
+          </a:prstGeom>
+          <a:solidFill>
+            <a:srgbClr val="065A82"/>
+          </a:solidFill>
+          <a:ln/>
+        </p:spPr>
+        <p:txBody>
+          <a:bodyPr/>
+          <a:lstStyle/>
+          <a:p>
+            <a:endParaRPr lang="es-CL"/>
+          </a:p>
+        </p:txBody>
+      </p:sp>
+      <p:sp>
+        <p:nvSpPr>
+          <p:cNvPr id="152" name="Text Num5"/>
+          <p:cNvSpPr/>
+          <p:nvPr/>
+        </p:nvSpPr>
+        <p:spPr>
+          <a:xfrm>
+            <a:off x="8382000" y="3913632"/>
+            <a:ext cx="502920" cy="502920"/>
+          </a:xfrm>
+          <a:prstGeom prst="rect">
+            <a:avLst/>
+          </a:prstGeom>
+          <a:noFill/>
+          <a:ln/>
+        </p:spPr>
+        <p:txBody>
+          <a:bodyPr wrap="square" rtlCol="0" anchor="ctr"/>
+          <a:lstStyle/>
+          <a:p>
+            <a:pPr marL="0" indent="0" algn="ctr">
+              <a:buNone/>
+            </a:pPr>
+            <a:r>
+              <a:rPr lang="en-US" sz="1300" b="1" dirty="0">
+                <a:solidFill>
+                  <a:srgbClr val="FFFFFF"/>
+                </a:solidFill>
+                <a:latin typeface="Cambria" pitchFamily="34" charset="0"/>
+                <a:ea typeface="Cambria" pitchFamily="34" charset="-122"/>
+                <a:cs typeface="Cambria" pitchFamily="34" charset="-120"/>
+              </a:rPr>
+              <a:t>06</a:t>
+            </a:r>
+            <a:endParaRPr lang="en-US" sz="1300" dirty="0"/>
+          </a:p>
+        </p:txBody>
+      </p:sp>
+      <p:sp>
+        <p:nvSpPr>
+          <p:cNvPr id="153" name="Text Title5"/>
+          <p:cNvSpPr/>
+          <p:nvPr/>
+        </p:nvSpPr>
+        <p:spPr>
+          <a:xfrm>
+            <a:off x="9040368" y="3858768"/>
+            <a:ext cx="2417064" cy="594360"/>
+          </a:xfrm>
+          <a:prstGeom prst="rect">
+            <a:avLst/>
+          </a:prstGeom>
+          <a:noFill/>
+          <a:ln/>
+        </p:spPr>
+        <p:txBody>
+          <a:bodyPr wrap="square" rtlCol="0" anchor="ctr"/>
+          <a:lstStyle/>
+          <a:p>
+            <a:pPr marL="0" indent="0" algn="l">
+              <a:buNone/>
+            </a:pPr>
+            <a:r>
+              <a:rPr lang="en-US" sz="1500" b="1" dirty="0">
+                <a:solidFill>
+                  <a:srgbClr val="21295C"/>
+                </a:solidFill>
+                <a:latin typeface="Cambria" pitchFamily="34" charset="0"/>
+                <a:ea typeface="Cambria" pitchFamily="34" charset="-122"/>
+                <a:cs typeface="Cambria" pitchFamily="34" charset="-120"/>
+              </a:rPr>
+              <a:t>EP-006 · Diagnóstico y Reportes</a:t>
+            </a:r>
+            <a:endParaRPr lang="en-US" sz="1500" dirty="0"/>
+          </a:p>
+        </p:txBody>
+      </p:sp>
+      <p:sp>
+        <p:nvSpPr>
+          <p:cNvPr id="154" name="Text Desc5"/>
+          <p:cNvSpPr/>
+          <p:nvPr/>
+        </p:nvSpPr>
+        <p:spPr>
+          <a:xfrm>
+            <a:off x="8382000" y="4617720"/>
+            <a:ext cx="3093720" cy="685800"/>
+          </a:xfrm>
+          <a:prstGeom prst="rect">
+            <a:avLst/>
+          </a:prstGeom>
+          <a:noFill/>
+          <a:ln/>
+        </p:spPr>
+        <p:txBody>
+          <a:bodyPr wrap="square" rtlCol="0" anchor="ctr"/>
+          <a:lstStyle/>
+          <a:p>
+            <a:pPr marL="0" indent="0" algn="l">
+              <a:buNone/>
+            </a:pPr>
+            <a:r>
+              <a:rPr lang="en-US" sz="1200" dirty="0">
+                <a:solidFill>
+                  <a:srgbClr val="5B6B79"/>
+                </a:solidFill>
+                <a:latin typeface="Calibri" pitchFamily="34" charset="0"/>
+                <a:ea typeface="Calibri" pitchFamily="34" charset="-122"/>
+                <a:cs typeface="Calibri" pitchFamily="34" charset="-120"/>
+              </a:rPr>
+              <a:t>Panel visual con resultados y errores</a:t>
             </a:r>
             <a:endParaRPr lang="en-US" dirty="0"/>
           </a:p>
@@ -12258,7 +11953,7 @@
                 <a:ea typeface="Calibri" pitchFamily="34" charset="-122"/>
                 <a:cs typeface="Calibri" pitchFamily="34" charset="-120"/>
               </a:rPr>
-              <a:t>31 Puntos de Función distribuidos en 4 épicas incrementales a lo largo de 10 semanas.</a:t>
+              <a:t>35 Puntos de Función distribuidos en 6 épicas incrementales a lo largo de 10 semanas.</a:t>
             </a:r>
             <a:endParaRPr lang="en-US" sz="1300" dirty="0"/>
           </a:p>
@@ -12336,7 +12031,7 @@
                 <a:ea typeface="Calibri" pitchFamily="34" charset="-122"/>
                 <a:cs typeface="Calibri" pitchFamily="34" charset="-120"/>
               </a:rPr>
-              <a:t>6</a:t>
+              <a:t>8</a:t>
             </a:r>
             <a:endParaRPr lang="en-US" sz="900" dirty="0"/>
           </a:p>
@@ -12629,7 +12324,7 @@
                 <a:ea typeface="Calibri" pitchFamily="34" charset="-122"/>
                 <a:cs typeface="Calibri" pitchFamily="34" charset="-120"/>
               </a:rPr>
-              <a:t>Arquitectura</a:t>
+              <a:t>Configuración</a:t>
             </a:r>
             <a:endParaRPr lang="en-US" sz="2000" dirty="0"/>
           </a:p>
@@ -12646,7 +12341,7 @@
                 <a:ea typeface="Calibri" pitchFamily="34" charset="-122"/>
                 <a:cs typeface="Calibri" pitchFamily="34" charset="-120"/>
               </a:rPr>
-              <a:t>base</a:t>
+              <a:t>&amp; escaneo</a:t>
             </a:r>
             <a:endParaRPr lang="en-US" sz="2000" dirty="0"/>
           </a:p>
@@ -12756,7 +12451,7 @@
                 <a:ea typeface="Calibri" pitchFamily="34" charset="-122"/>
                 <a:cs typeface="Calibri" pitchFamily="34" charset="-120"/>
               </a:rPr>
-              <a:t>Automatización</a:t>
+              <a:t>Escenarios</a:t>
             </a:r>
             <a:endParaRPr lang="en-US" sz="2000" dirty="0"/>
           </a:p>
@@ -12773,7 +12468,7 @@
                 <a:ea typeface="Calibri" pitchFamily="34" charset="-122"/>
                 <a:cs typeface="Calibri" pitchFamily="34" charset="-120"/>
               </a:rPr>
-              <a:t>UI</a:t>
+              <a:t>&amp; adaptabilidad</a:t>
             </a:r>
             <a:endParaRPr lang="en-US" sz="2000" dirty="0"/>
           </a:p>
@@ -12883,7 +12578,7 @@
                 <a:ea typeface="Calibri" pitchFamily="34" charset="-122"/>
                 <a:cs typeface="Calibri" pitchFamily="34" charset="-120"/>
               </a:rPr>
-              <a:t>Orquestación</a:t>
+              <a:t>Ejecución</a:t>
             </a:r>
             <a:endParaRPr lang="en-US" sz="2000" dirty="0"/>
           </a:p>
@@ -13010,7 +12705,7 @@
                 <a:ea typeface="Calibri" pitchFamily="34" charset="-122"/>
                 <a:cs typeface="Calibri" pitchFamily="34" charset="-120"/>
               </a:rPr>
-              <a:t>Monitoreo</a:t>
+              <a:t>Diagnóstico</a:t>
             </a:r>
             <a:endParaRPr lang="en-US" sz="2000" dirty="0"/>
           </a:p>
@@ -13027,7 +12722,7 @@
                 <a:ea typeface="Calibri" pitchFamily="34" charset="-122"/>
                 <a:cs typeface="Calibri" pitchFamily="34" charset="-120"/>
               </a:rPr>
-              <a:t>&amp; dashboard</a:t>
+              <a:t>&amp; reportes</a:t>
             </a:r>
             <a:endParaRPr lang="en-US" sz="2000" dirty="0"/>
           </a:p>
@@ -13091,7 +12786,7 @@
                 <a:ea typeface="Calibri" pitchFamily="34" charset="-122"/>
                 <a:cs typeface="Calibri" pitchFamily="34" charset="-120"/>
               </a:rPr>
-              <a:t>Dimensionamiento del esfuerzo mediante Poker Planning (31 Puntos de Función)</a:t>
+              <a:t>Dimensionamiento del esfuerzo mediante Poker Planning (35 Puntos de Función)</a:t>
             </a:r>
             <a:endParaRPr lang="en-US" dirty="0"/>
           </a:p>
@@ -13211,7 +12906,7 @@
                 <a:ea typeface="Calibri" pitchFamily="34" charset="-122"/>
                 <a:cs typeface="Calibri" pitchFamily="34" charset="-120"/>
               </a:rPr>
-              <a:t>7</a:t>
+              <a:t>9</a:t>
             </a:r>
             <a:endParaRPr lang="en-US" sz="900" dirty="0"/>
           </a:p>

</xml_diff>